<commit_message>
Add Option 1 potential risk and a one-page Step 3 schedule.
The five-slide deck now states the hold-up risk for Option 1. The one-page version carries all three options and the phase matrix.

Co-authored-by: peterli0913 <peterli0913@users.noreply.github.com>
</commit_message>
<xml_diff>
--- a/139788 Step 3 Dead-leg and Hold-up Retrofit_EN.pptx
+++ b/139788 Step 3 Dead-leg and Hold-up Retrofit_EN.pptx
@@ -4442,8 +4442,8 @@
         </p:nvSpPr>
         <p:spPr>
           <a:xfrm>
-            <a:off x="502920" y="1170432"/>
-            <a:ext cx="10972800" cy="292608"/>
+            <a:off x="502920" y="1078992"/>
+            <a:ext cx="10972800" cy="256032"/>
           </a:xfrm>
           <a:prstGeom prst="rect">
             <a:avLst/>
@@ -4484,18 +4484,18 @@
         </p:nvSpPr>
         <p:spPr>
           <a:xfrm>
-            <a:off x="502920" y="1645920"/>
-            <a:ext cx="5486400" cy="3063240"/>
+            <a:off x="502920" y="1417320"/>
+            <a:ext cx="11201400" cy="1115568"/>
           </a:xfrm>
           <a:prstGeom prst="rect">
             <a:avLst/>
           </a:prstGeom>
           <a:solidFill>
-            <a:srgbClr val="F7FBFB"/>
+            <a:srgbClr val="F8EEEE"/>
           </a:solidFill>
           <a:ln w="12700">
             <a:solidFill>
-              <a:srgbClr val="D5E3E3"/>
+              <a:srgbClr val="E4C8C8"/>
             </a:solidFill>
           </a:ln>
           <a:effectLst/>
@@ -4524,14 +4524,98 @@
       </p:sp>
       <p:sp>
         <p:nvSpPr>
-          <p:cNvPr id="7" name="Rectangle 6"/>
+          <p:cNvPr id="7" name="TextBox 6"/>
+          <p:cNvSpPr txBox="1"/>
+          <p:nvPr/>
+        </p:nvSpPr>
+        <p:spPr>
+          <a:xfrm>
+            <a:off x="685800" y="1499616"/>
+            <a:ext cx="3657600" cy="201168"/>
+          </a:xfrm>
+          <a:prstGeom prst="rect">
+            <a:avLst/>
+          </a:prstGeom>
+          <a:noFill/>
+        </p:spPr>
+        <p:txBody>
+          <a:bodyPr wrap="square" lIns="0" rIns="0" tIns="0" bIns="0" anchor="t"/>
+          <a:lstStyle/>
+          <a:p>
+            <a:pPr algn="l">
+              <a:spcBef>
+                <a:spcPts val="0"/>
+              </a:spcBef>
+              <a:spcAft>
+                <a:spcPts val="0"/>
+              </a:spcAft>
+            </a:pPr>
+            <a:r>
+              <a:rPr sz="1200" b="1">
+                <a:solidFill>
+                  <a:srgbClr val="8C3A3A"/>
+                </a:solidFill>
+                <a:latin typeface="DejaVu Sans"/>
+                <a:ea typeface="DejaVu Sans"/>
+                <a:cs typeface="DejaVu Sans"/>
+              </a:rPr>
+              <a:t>POTENTIAL RISK</a:t>
+            </a:r>
+          </a:p>
+        </p:txBody>
+      </p:sp>
+      <p:sp>
+        <p:nvSpPr>
+          <p:cNvPr id="8" name="TextBox 7"/>
+          <p:cNvSpPr txBox="1"/>
+          <p:nvPr/>
+        </p:nvSpPr>
+        <p:spPr>
+          <a:xfrm>
+            <a:off x="685800" y="1737360"/>
+            <a:ext cx="10835640" cy="658368"/>
+          </a:xfrm>
+          <a:prstGeom prst="rect">
+            <a:avLst/>
+          </a:prstGeom>
+          <a:noFill/>
+        </p:spPr>
+        <p:txBody>
+          <a:bodyPr wrap="square" lIns="0" rIns="0" tIns="0" bIns="0" anchor="t"/>
+          <a:lstStyle/>
+          <a:p>
+            <a:pPr algn="l">
+              <a:spcBef>
+                <a:spcPts val="0"/>
+              </a:spcBef>
+              <a:spcAft>
+                <a:spcPts val="0"/>
+              </a:spcAft>
+            </a:pPr>
+            <a:r>
+              <a:rPr sz="1500" b="0">
+                <a:solidFill>
+                  <a:srgbClr val="1C2833"/>
+                </a:solidFill>
+                <a:latin typeface="DejaVu Sans"/>
+                <a:ea typeface="DejaVu Sans"/>
+                <a:cs typeface="DejaVu Sans"/>
+              </a:rPr>
+              <a:t>Hold-up in the piping can degrade the material, support microbial growth, or cause cross-contamination. The flush, drain, purge, and disassembly required after each use are not defined.</a:t>
+            </a:r>
+          </a:p>
+        </p:txBody>
+      </p:sp>
+      <p:sp>
+        <p:nvSpPr>
+          <p:cNvPr id="9" name="Rectangle 8"/>
           <p:cNvSpPr/>
           <p:nvPr/>
         </p:nvSpPr>
         <p:spPr>
           <a:xfrm>
-            <a:off x="6172200" y="1645920"/>
-            <a:ext cx="5532120" cy="3063240"/>
+            <a:off x="502920" y="2697480"/>
+            <a:ext cx="5486400" cy="2011680"/>
           </a:xfrm>
           <a:prstGeom prst="rect">
             <a:avLst/>
@@ -4570,255 +4654,20 @@
       </p:sp>
       <p:sp>
         <p:nvSpPr>
-          <p:cNvPr id="8" name="TextBox 7"/>
-          <p:cNvSpPr txBox="1"/>
-          <p:nvPr/>
-        </p:nvSpPr>
-        <p:spPr>
-          <a:xfrm>
-            <a:off x="713232" y="1810512"/>
-            <a:ext cx="5029200" cy="256032"/>
-          </a:xfrm>
-          <a:prstGeom prst="rect">
-            <a:avLst/>
-          </a:prstGeom>
-          <a:noFill/>
-        </p:spPr>
-        <p:txBody>
-          <a:bodyPr wrap="square" lIns="0" rIns="0" tIns="0" bIns="0" anchor="t"/>
-          <a:lstStyle/>
-          <a:p>
-            <a:pPr algn="l">
-              <a:spcBef>
-                <a:spcPts val="0"/>
-              </a:spcBef>
-              <a:spcAft>
-                <a:spcPts val="0"/>
-              </a:spcAft>
-            </a:pPr>
-            <a:r>
-              <a:rPr sz="1200" b="1">
-                <a:solidFill>
-                  <a:srgbClr val="2D8B8B"/>
-                </a:solidFill>
-                <a:latin typeface="DejaVu Sans"/>
-                <a:ea typeface="DejaVu Sans"/>
-                <a:cs typeface="DejaVu Sans"/>
-              </a:rPr>
-              <a:t>WHAT REMAINS</a:t>
-            </a:r>
-          </a:p>
-        </p:txBody>
-      </p:sp>
-      <p:sp>
-        <p:nvSpPr>
-          <p:cNvPr id="9" name="TextBox 8"/>
-          <p:cNvSpPr txBox="1"/>
-          <p:nvPr/>
-        </p:nvSpPr>
-        <p:spPr>
-          <a:xfrm>
-            <a:off x="713232" y="2194560"/>
-            <a:ext cx="5029200" cy="2194560"/>
-          </a:xfrm>
-          <a:prstGeom prst="rect">
-            <a:avLst/>
-          </a:prstGeom>
-          <a:noFill/>
-        </p:spPr>
-        <p:txBody>
-          <a:bodyPr wrap="square" lIns="0" rIns="0" tIns="0" bIns="0">
-            <a:spAutoFit/>
-          </a:bodyPr>
-          <a:lstStyle/>
-          <a:p>
-            <a:pPr algn="l">
-              <a:spcBef>
-                <a:spcPts val="0"/>
-              </a:spcBef>
-              <a:spcAft>
-                <a:spcPts val="0"/>
-              </a:spcAft>
-            </a:pPr>
-            <a:r>
-              <a:rPr sz="1500" b="0">
-                <a:solidFill>
-                  <a:srgbClr val="1C2833"/>
-                </a:solidFill>
-                <a:latin typeface="DejaVu Sans"/>
-                <a:ea typeface="DejaVu Sans"/>
-                <a:cs typeface="DejaVu Sans"/>
-              </a:rPr>
-              <a:t>Some piping does not meet the 2D/3D dead-leg criterion.</a:t>
-            </a:r>
-          </a:p>
-          <a:p>
-            <a:pPr algn="l">
-              <a:spcBef>
-                <a:spcPts val="1000"/>
-              </a:spcBef>
-              <a:spcAft>
-                <a:spcPts val="0"/>
-              </a:spcAft>
-            </a:pPr>
-            <a:r>
-              <a:rPr sz="1500" b="0">
-                <a:solidFill>
-                  <a:srgbClr val="1C2833"/>
-                </a:solidFill>
-                <a:latin typeface="DejaVu Sans"/>
-                <a:ea typeface="DejaVu Sans"/>
-                <a:cs typeface="DejaVu Sans"/>
-              </a:rPr>
-              <a:t>Some diaphragm valves do not meet the self-draining requirement.</a:t>
-            </a:r>
-          </a:p>
-          <a:p>
-            <a:pPr algn="l">
-              <a:spcBef>
-                <a:spcPts val="1000"/>
-              </a:spcBef>
-              <a:spcAft>
-                <a:spcPts val="0"/>
-              </a:spcAft>
-            </a:pPr>
-            <a:r>
-              <a:rPr sz="1500" b="0">
-                <a:solidFill>
-                  <a:srgbClr val="1C2833"/>
-                </a:solidFill>
-                <a:latin typeface="DejaVu Sans"/>
-                <a:ea typeface="DejaVu Sans"/>
-                <a:cs typeface="DejaVu Sans"/>
-              </a:rPr>
-              <a:t>Some piping is not ASME BPE piping.</a:t>
-            </a:r>
-          </a:p>
-        </p:txBody>
-      </p:sp>
-      <p:sp>
-        <p:nvSpPr>
-          <p:cNvPr id="10" name="TextBox 9"/>
-          <p:cNvSpPr txBox="1"/>
-          <p:nvPr/>
-        </p:nvSpPr>
-        <p:spPr>
-          <a:xfrm>
-            <a:off x="6382512" y="1810512"/>
-            <a:ext cx="5029200" cy="256032"/>
-          </a:xfrm>
-          <a:prstGeom prst="rect">
-            <a:avLst/>
-          </a:prstGeom>
-          <a:noFill/>
-        </p:spPr>
-        <p:txBody>
-          <a:bodyPr wrap="square" lIns="0" rIns="0" tIns="0" bIns="0" anchor="t"/>
-          <a:lstStyle/>
-          <a:p>
-            <a:pPr algn="l">
-              <a:spcBef>
-                <a:spcPts val="0"/>
-              </a:spcBef>
-              <a:spcAft>
-                <a:spcPts val="0"/>
-              </a:spcAft>
-            </a:pPr>
-            <a:r>
-              <a:rPr sz="1200" b="1">
-                <a:solidFill>
-                  <a:srgbClr val="2D8B8B"/>
-                </a:solidFill>
-                <a:latin typeface="DejaVu Sans"/>
-                <a:ea typeface="DejaVu Sans"/>
-                <a:cs typeface="DejaVu Sans"/>
-              </a:rPr>
-              <a:t>WHAT WE WILL ADD</a:t>
-            </a:r>
-          </a:p>
-        </p:txBody>
-      </p:sp>
-      <p:sp>
-        <p:nvSpPr>
-          <p:cNvPr id="11" name="TextBox 10"/>
-          <p:cNvSpPr txBox="1"/>
-          <p:nvPr/>
-        </p:nvSpPr>
-        <p:spPr>
-          <a:xfrm>
-            <a:off x="6382512" y="2194560"/>
-            <a:ext cx="5074920" cy="2194560"/>
-          </a:xfrm>
-          <a:prstGeom prst="rect">
-            <a:avLst/>
-          </a:prstGeom>
-          <a:noFill/>
-        </p:spPr>
-        <p:txBody>
-          <a:bodyPr wrap="square" lIns="0" rIns="0" tIns="0" bIns="0">
-            <a:spAutoFit/>
-          </a:bodyPr>
-          <a:lstStyle/>
-          <a:p>
-            <a:pPr algn="l">
-              <a:spcBef>
-                <a:spcPts val="0"/>
-              </a:spcBef>
-              <a:spcAft>
-                <a:spcPts val="0"/>
-              </a:spcAft>
-            </a:pPr>
-            <a:r>
-              <a:rPr sz="1500" b="0">
-                <a:solidFill>
-                  <a:srgbClr val="1C2833"/>
-                </a:solidFill>
-                <a:latin typeface="DejaVu Sans"/>
-                <a:ea typeface="DejaVu Sans"/>
-                <a:cs typeface="DejaVu Sans"/>
-              </a:rPr>
-              <a:t>After each system transfer, flush or clean with process solvent. Bioburden data support this step.</a:t>
-            </a:r>
-          </a:p>
-          <a:p>
-            <a:pPr algn="l">
-              <a:spcBef>
-                <a:spcPts val="1000"/>
-              </a:spcBef>
-              <a:spcAft>
-                <a:spcPts val="0"/>
-              </a:spcAft>
-            </a:pPr>
-            <a:r>
-              <a:rPr sz="1500" b="0">
-                <a:solidFill>
-                  <a:srgbClr val="1C2833"/>
-                </a:solidFill>
-                <a:latin typeface="DejaVu Sans"/>
-                <a:ea typeface="DejaVu Sans"/>
-                <a:cs typeface="DejaVu Sans"/>
-              </a:rPr>
-              <a:t>Write the flush, drain, purge, and disassembly requirements into the operating and cleaning procedures.</a:t>
-            </a:r>
-          </a:p>
-        </p:txBody>
-      </p:sp>
-      <p:sp>
-        <p:nvSpPr>
-          <p:cNvPr id="12" name="Rectangle 11"/>
+          <p:cNvPr id="10" name="Rectangle 9"/>
           <p:cNvSpPr/>
           <p:nvPr/>
         </p:nvSpPr>
         <p:spPr>
           <a:xfrm>
-            <a:off x="502920" y="4892040"/>
-            <a:ext cx="7635240" cy="1325880"/>
+            <a:off x="6172200" y="2697480"/>
+            <a:ext cx="5532120" cy="2011680"/>
           </a:xfrm>
           <a:prstGeom prst="rect">
             <a:avLst/>
           </a:prstGeom>
           <a:solidFill>
-            <a:srgbClr val="FFFFFF"/>
+            <a:srgbClr val="F7FBFB"/>
           </a:solidFill>
           <a:ln w="12700">
             <a:solidFill>
@@ -4851,23 +4700,260 @@
       </p:sp>
       <p:sp>
         <p:nvSpPr>
-          <p:cNvPr id="13" name="Rectangle 12"/>
+          <p:cNvPr id="11" name="TextBox 10"/>
+          <p:cNvSpPr txBox="1"/>
+          <p:nvPr/>
+        </p:nvSpPr>
+        <p:spPr>
+          <a:xfrm>
+            <a:off x="713232" y="2816352"/>
+            <a:ext cx="5029200" cy="219456"/>
+          </a:xfrm>
+          <a:prstGeom prst="rect">
+            <a:avLst/>
+          </a:prstGeom>
+          <a:noFill/>
+        </p:spPr>
+        <p:txBody>
+          <a:bodyPr wrap="square" lIns="0" rIns="0" tIns="0" bIns="0" anchor="t"/>
+          <a:lstStyle/>
+          <a:p>
+            <a:pPr algn="l">
+              <a:spcBef>
+                <a:spcPts val="0"/>
+              </a:spcBef>
+              <a:spcAft>
+                <a:spcPts val="0"/>
+              </a:spcAft>
+            </a:pPr>
+            <a:r>
+              <a:rPr sz="1200" b="1">
+                <a:solidFill>
+                  <a:srgbClr val="2D8B8B"/>
+                </a:solidFill>
+                <a:latin typeface="DejaVu Sans"/>
+                <a:ea typeface="DejaVu Sans"/>
+                <a:cs typeface="DejaVu Sans"/>
+              </a:rPr>
+              <a:t>WHAT REMAINS</a:t>
+            </a:r>
+          </a:p>
+        </p:txBody>
+      </p:sp>
+      <p:sp>
+        <p:nvSpPr>
+          <p:cNvPr id="12" name="TextBox 11"/>
+          <p:cNvSpPr txBox="1"/>
+          <p:nvPr/>
+        </p:nvSpPr>
+        <p:spPr>
+          <a:xfrm>
+            <a:off x="713232" y="3090672"/>
+            <a:ext cx="5029200" cy="1463040"/>
+          </a:xfrm>
+          <a:prstGeom prst="rect">
+            <a:avLst/>
+          </a:prstGeom>
+          <a:noFill/>
+        </p:spPr>
+        <p:txBody>
+          <a:bodyPr wrap="square" lIns="0" rIns="0" tIns="0" bIns="0">
+            <a:spAutoFit/>
+          </a:bodyPr>
+          <a:lstStyle/>
+          <a:p>
+            <a:pPr algn="l">
+              <a:spcBef>
+                <a:spcPts val="0"/>
+              </a:spcBef>
+              <a:spcAft>
+                <a:spcPts val="0"/>
+              </a:spcAft>
+            </a:pPr>
+            <a:r>
+              <a:rPr sz="1400" b="0">
+                <a:solidFill>
+                  <a:srgbClr val="1C2833"/>
+                </a:solidFill>
+                <a:latin typeface="DejaVu Sans"/>
+                <a:ea typeface="DejaVu Sans"/>
+                <a:cs typeface="DejaVu Sans"/>
+              </a:rPr>
+              <a:t>Some piping does not meet the 2D/3D dead-leg criterion.</a:t>
+            </a:r>
+          </a:p>
+          <a:p>
+            <a:pPr algn="l">
+              <a:spcBef>
+                <a:spcPts val="600"/>
+              </a:spcBef>
+              <a:spcAft>
+                <a:spcPts val="0"/>
+              </a:spcAft>
+            </a:pPr>
+            <a:r>
+              <a:rPr sz="1400" b="0">
+                <a:solidFill>
+                  <a:srgbClr val="1C2833"/>
+                </a:solidFill>
+                <a:latin typeface="DejaVu Sans"/>
+                <a:ea typeface="DejaVu Sans"/>
+                <a:cs typeface="DejaVu Sans"/>
+              </a:rPr>
+              <a:t>Some diaphragm valves do not meet the self-draining requirement.</a:t>
+            </a:r>
+          </a:p>
+          <a:p>
+            <a:pPr algn="l">
+              <a:spcBef>
+                <a:spcPts val="600"/>
+              </a:spcBef>
+              <a:spcAft>
+                <a:spcPts val="0"/>
+              </a:spcAft>
+            </a:pPr>
+            <a:r>
+              <a:rPr sz="1400" b="0">
+                <a:solidFill>
+                  <a:srgbClr val="1C2833"/>
+                </a:solidFill>
+                <a:latin typeface="DejaVu Sans"/>
+                <a:ea typeface="DejaVu Sans"/>
+                <a:cs typeface="DejaVu Sans"/>
+              </a:rPr>
+              <a:t>Some piping is not ASME BPE piping.</a:t>
+            </a:r>
+          </a:p>
+        </p:txBody>
+      </p:sp>
+      <p:sp>
+        <p:nvSpPr>
+          <p:cNvPr id="13" name="TextBox 12"/>
+          <p:cNvSpPr txBox="1"/>
+          <p:nvPr/>
+        </p:nvSpPr>
+        <p:spPr>
+          <a:xfrm>
+            <a:off x="6382512" y="2816352"/>
+            <a:ext cx="5029200" cy="219456"/>
+          </a:xfrm>
+          <a:prstGeom prst="rect">
+            <a:avLst/>
+          </a:prstGeom>
+          <a:noFill/>
+        </p:spPr>
+        <p:txBody>
+          <a:bodyPr wrap="square" lIns="0" rIns="0" tIns="0" bIns="0" anchor="t"/>
+          <a:lstStyle/>
+          <a:p>
+            <a:pPr algn="l">
+              <a:spcBef>
+                <a:spcPts val="0"/>
+              </a:spcBef>
+              <a:spcAft>
+                <a:spcPts val="0"/>
+              </a:spcAft>
+            </a:pPr>
+            <a:r>
+              <a:rPr sz="1200" b="1">
+                <a:solidFill>
+                  <a:srgbClr val="2D8B8B"/>
+                </a:solidFill>
+                <a:latin typeface="DejaVu Sans"/>
+                <a:ea typeface="DejaVu Sans"/>
+                <a:cs typeface="DejaVu Sans"/>
+              </a:rPr>
+              <a:t>WHAT WE WILL ADD</a:t>
+            </a:r>
+          </a:p>
+        </p:txBody>
+      </p:sp>
+      <p:sp>
+        <p:nvSpPr>
+          <p:cNvPr id="14" name="TextBox 13"/>
+          <p:cNvSpPr txBox="1"/>
+          <p:nvPr/>
+        </p:nvSpPr>
+        <p:spPr>
+          <a:xfrm>
+            <a:off x="6382512" y="3090672"/>
+            <a:ext cx="5074920" cy="1463040"/>
+          </a:xfrm>
+          <a:prstGeom prst="rect">
+            <a:avLst/>
+          </a:prstGeom>
+          <a:noFill/>
+        </p:spPr>
+        <p:txBody>
+          <a:bodyPr wrap="square" lIns="0" rIns="0" tIns="0" bIns="0">
+            <a:spAutoFit/>
+          </a:bodyPr>
+          <a:lstStyle/>
+          <a:p>
+            <a:pPr algn="l">
+              <a:spcBef>
+                <a:spcPts val="0"/>
+              </a:spcBef>
+              <a:spcAft>
+                <a:spcPts val="0"/>
+              </a:spcAft>
+            </a:pPr>
+            <a:r>
+              <a:rPr sz="1400" b="0">
+                <a:solidFill>
+                  <a:srgbClr val="1C2833"/>
+                </a:solidFill>
+                <a:latin typeface="DejaVu Sans"/>
+                <a:ea typeface="DejaVu Sans"/>
+                <a:cs typeface="DejaVu Sans"/>
+              </a:rPr>
+              <a:t>After each system transfer, flush or clean with process solvent. Bioburden data support this step.</a:t>
+            </a:r>
+          </a:p>
+          <a:p>
+            <a:pPr algn="l">
+              <a:spcBef>
+                <a:spcPts val="600"/>
+              </a:spcBef>
+              <a:spcAft>
+                <a:spcPts val="0"/>
+              </a:spcAft>
+            </a:pPr>
+            <a:r>
+              <a:rPr sz="1400" b="0">
+                <a:solidFill>
+                  <a:srgbClr val="1C2833"/>
+                </a:solidFill>
+                <a:latin typeface="DejaVu Sans"/>
+                <a:ea typeface="DejaVu Sans"/>
+                <a:cs typeface="DejaVu Sans"/>
+              </a:rPr>
+              <a:t>Write the flush, drain, purge, and disassembly requirements into the procedures.</a:t>
+            </a:r>
+          </a:p>
+        </p:txBody>
+      </p:sp>
+      <p:sp>
+        <p:nvSpPr>
+          <p:cNvPr id="15" name="Rectangle 14"/>
           <p:cNvSpPr/>
           <p:nvPr/>
         </p:nvSpPr>
         <p:spPr>
           <a:xfrm>
-            <a:off x="8275320" y="4892040"/>
-            <a:ext cx="3429000" cy="1325880"/>
+            <a:off x="502920" y="4892040"/>
+            <a:ext cx="7635240" cy="1325880"/>
           </a:xfrm>
           <a:prstGeom prst="rect">
             <a:avLst/>
           </a:prstGeom>
           <a:solidFill>
-            <a:srgbClr val="1A2332"/>
+            <a:srgbClr val="FFFFFF"/>
           </a:solidFill>
-          <a:ln>
-            <a:noFill/>
+          <a:ln w="12700">
+            <a:solidFill>
+              <a:srgbClr val="D5E3E3"/>
+            </a:solidFill>
           </a:ln>
           <a:effectLst/>
         </p:spPr>
@@ -4895,7 +4981,51 @@
       </p:sp>
       <p:sp>
         <p:nvSpPr>
-          <p:cNvPr id="14" name="TextBox 13"/>
+          <p:cNvPr id="16" name="Rectangle 15"/>
+          <p:cNvSpPr/>
+          <p:nvPr/>
+        </p:nvSpPr>
+        <p:spPr>
+          <a:xfrm>
+            <a:off x="8275320" y="4892040"/>
+            <a:ext cx="3429000" cy="1325880"/>
+          </a:xfrm>
+          <a:prstGeom prst="rect">
+            <a:avLst/>
+          </a:prstGeom>
+          <a:solidFill>
+            <a:srgbClr val="1A2332"/>
+          </a:solidFill>
+          <a:ln>
+            <a:noFill/>
+          </a:ln>
+          <a:effectLst/>
+        </p:spPr>
+        <p:style>
+          <a:lnRef idx="1">
+            <a:schemeClr val="accent1"/>
+          </a:lnRef>
+          <a:fillRef idx="3">
+            <a:schemeClr val="accent1"/>
+          </a:fillRef>
+          <a:effectRef idx="2">
+            <a:schemeClr val="accent1"/>
+          </a:effectRef>
+          <a:fontRef idx="minor">
+            <a:schemeClr val="lt1"/>
+          </a:fontRef>
+        </p:style>
+        <p:txBody>
+          <a:bodyPr rtlCol="0" anchor="ctr"/>
+          <a:lstStyle/>
+          <a:p>
+            <a:pPr algn="ctr"/>
+          </a:p>
+        </p:txBody>
+      </p:sp>
+      <p:sp>
+        <p:nvSpPr>
+          <p:cNvPr id="17" name="TextBox 16"/>
           <p:cNvSpPr txBox="1"/>
           <p:nvPr/>
         </p:nvSpPr>
@@ -4937,7 +5067,7 @@
       </p:sp>
       <p:sp>
         <p:nvSpPr>
-          <p:cNvPr id="15" name="TextBox 14"/>
+          <p:cNvPr id="18" name="TextBox 17"/>
           <p:cNvSpPr txBox="1"/>
           <p:nvPr/>
         </p:nvSpPr>
@@ -4979,7 +5109,7 @@
       </p:sp>
       <p:sp>
         <p:nvSpPr>
-          <p:cNvPr id="16" name="TextBox 15"/>
+          <p:cNvPr id="19" name="TextBox 18"/>
           <p:cNvSpPr txBox="1"/>
           <p:nvPr/>
         </p:nvSpPr>
@@ -5021,7 +5151,7 @@
       </p:sp>
       <p:sp>
         <p:nvSpPr>
-          <p:cNvPr id="17" name="TextBox 16"/>
+          <p:cNvPr id="20" name="TextBox 19"/>
           <p:cNvSpPr txBox="1"/>
           <p:nvPr/>
         </p:nvSpPr>
@@ -5063,7 +5193,7 @@
       </p:sp>
       <p:sp>
         <p:nvSpPr>
-          <p:cNvPr id="18" name="TextBox 17"/>
+          <p:cNvPr id="21" name="TextBox 20"/>
           <p:cNvSpPr txBox="1"/>
           <p:nvPr/>
         </p:nvSpPr>
@@ -5105,7 +5235,7 @@
       </p:sp>
       <p:sp>
         <p:nvSpPr>
-          <p:cNvPr id="19" name="TextBox 18"/>
+          <p:cNvPr id="22" name="TextBox 21"/>
           <p:cNvSpPr txBox="1"/>
           <p:nvPr/>
         </p:nvSpPr>

</xml_diff>

<commit_message>
Update 139788 Step 3 Dead-leg and Hold-up Retrofit_EN.pptx
</commit_message>
<xml_diff>
--- a/139788 Step 3 Dead-leg and Hold-up Retrofit_EN.pptx
+++ b/139788 Step 3 Dead-leg and Hold-up Retrofit_EN.pptx
@@ -1,17 +1,17 @@
 
 <file path=ppt/presentation.xml><?xml version="1.0" encoding="utf-8"?>
-<p:presentation xmlns:a="http://schemas.openxmlformats.org/drawingml/2006/main" xmlns:r="http://schemas.openxmlformats.org/officeDocument/2006/relationships" xmlns:p="http://schemas.openxmlformats.org/presentationml/2006/main" saveSubsetFonts="1" autoCompressPictures="0">
+<p:presentation xmlns:a="http://schemas.openxmlformats.org/drawingml/2006/main" xmlns:r="http://schemas.openxmlformats.org/officeDocument/2006/relationships" xmlns:p="http://schemas.openxmlformats.org/presentationml/2006/main" autoCompressPictures="0">
   <p:sldMasterIdLst>
     <p:sldMasterId id="2147483648" r:id="rId1"/>
   </p:sldMasterIdLst>
   <p:sldIdLst>
-    <p:sldId id="256" r:id="rId7"/>
-    <p:sldId id="257" r:id="rId8"/>
-    <p:sldId id="258" r:id="rId9"/>
-    <p:sldId id="259" r:id="rId10"/>
-    <p:sldId id="260" r:id="rId11"/>
+    <p:sldId id="256" r:id="rId3"/>
+    <p:sldId id="257" r:id="rId4"/>
+    <p:sldId id="258" r:id="rId5"/>
+    <p:sldId id="259" r:id="rId6"/>
+    <p:sldId id="260" r:id="rId7"/>
   </p:sldIdLst>
-  <p:sldSz cx="12191695" cy="6858000" type="screen4x3"/>
+  <p:sldSz cx="12191365" cy="6858000" type="screen4x3"/>
   <p:notesSz cx="6858000" cy="9144000"/>
   <p:defaultTextStyle>
     <a:defPPr>
@@ -108,6 +108,22 @@
       </a:defRPr>
     </a:lvl9pPr>
   </p:defaultTextStyle>
+  <p:extLst>
+    <p:ext uri="{EFAFB233-063F-42B5-8137-9DF3F51BA10A}">
+      <p15:sldGuideLst xmlns:p15="http://schemas.microsoft.com/office/powerpoint/2012/main">
+        <p15:guide id="1" orient="horz" pos="2160" userDrawn="1">
+          <p15:clr>
+            <a:srgbClr val="A4A3A4"/>
+          </p15:clr>
+        </p15:guide>
+        <p15:guide id="2" pos="2880" userDrawn="1">
+          <p15:clr>
+            <a:srgbClr val="A4A3A4"/>
+          </p15:clr>
+        </p15:guide>
+      </p15:sldGuideLst>
+    </p:ext>
+  </p:extLst>
 </p:presentation>
 </file>
 
@@ -292,7 +308,6 @@
           <a:p>
             <a:fld id="{5BCAD085-E8A6-8845-BD4E-CB4CCA059FC4}" type="datetimeFigureOut">
               <a:rPr lang="en-US" smtClean="0"/>
-              <a:t>1/27/13</a:t>
             </a:fld>
             <a:endParaRPr lang="en-US"/>
           </a:p>
@@ -334,18 +349,12 @@
           <a:p>
             <a:fld id="{C1FF6DA9-008F-8B48-92A6-B652298478BF}" type="slidenum">
               <a:rPr lang="en-US" smtClean="0"/>
-              <a:t>‹#›</a:t>
             </a:fld>
             <a:endParaRPr lang="en-US"/>
           </a:p>
         </p:txBody>
       </p:sp>
     </p:spTree>
-    <p:extLst>
-      <p:ext uri="{BB962C8B-B14F-4D97-AF65-F5344CB8AC3E}">
-        <p14:creationId xmlns:p14="http://schemas.microsoft.com/office/powerpoint/2010/main" val="3168075583"/>
-      </p:ext>
-    </p:extLst>
   </p:cSld>
   <p:clrMapOvr>
     <a:masterClrMapping/>
@@ -413,6 +422,7 @@
               <a:rPr lang="en-US" smtClean="0"/>
               <a:t>Click to edit Master text styles</a:t>
             </a:r>
+            <a:endParaRPr lang="en-US" smtClean="0"/>
           </a:p>
           <a:p>
             <a:pPr lvl="1"/>
@@ -420,6 +430,7 @@
               <a:rPr lang="en-US" smtClean="0"/>
               <a:t>Second level</a:t>
             </a:r>
+            <a:endParaRPr lang="en-US" smtClean="0"/>
           </a:p>
           <a:p>
             <a:pPr lvl="2"/>
@@ -427,6 +438,7 @@
               <a:rPr lang="en-US" smtClean="0"/>
               <a:t>Third level</a:t>
             </a:r>
+            <a:endParaRPr lang="en-US" smtClean="0"/>
           </a:p>
           <a:p>
             <a:pPr lvl="3"/>
@@ -434,6 +446,7 @@
               <a:rPr lang="en-US" smtClean="0"/>
               <a:t>Fourth level</a:t>
             </a:r>
+            <a:endParaRPr lang="en-US" smtClean="0"/>
           </a:p>
           <a:p>
             <a:pPr lvl="4"/>
@@ -462,7 +475,6 @@
           <a:p>
             <a:fld id="{5BCAD085-E8A6-8845-BD4E-CB4CCA059FC4}" type="datetimeFigureOut">
               <a:rPr lang="en-US" smtClean="0"/>
-              <a:t>1/27/13</a:t>
             </a:fld>
             <a:endParaRPr lang="en-US"/>
           </a:p>
@@ -504,18 +516,12 @@
           <a:p>
             <a:fld id="{C1FF6DA9-008F-8B48-92A6-B652298478BF}" type="slidenum">
               <a:rPr lang="en-US" smtClean="0"/>
-              <a:t>‹#›</a:t>
             </a:fld>
             <a:endParaRPr lang="en-US"/>
           </a:p>
         </p:txBody>
       </p:sp>
     </p:spTree>
-    <p:extLst>
-      <p:ext uri="{BB962C8B-B14F-4D97-AF65-F5344CB8AC3E}">
-        <p14:creationId xmlns:p14="http://schemas.microsoft.com/office/powerpoint/2010/main" val="2910927964"/>
-      </p:ext>
-    </p:extLst>
   </p:cSld>
   <p:clrMapOvr>
     <a:masterClrMapping/>
@@ -593,6 +599,7 @@
               <a:rPr lang="en-US" smtClean="0"/>
               <a:t>Click to edit Master text styles</a:t>
             </a:r>
+            <a:endParaRPr lang="en-US" smtClean="0"/>
           </a:p>
           <a:p>
             <a:pPr lvl="1"/>
@@ -600,6 +607,7 @@
               <a:rPr lang="en-US" smtClean="0"/>
               <a:t>Second level</a:t>
             </a:r>
+            <a:endParaRPr lang="en-US" smtClean="0"/>
           </a:p>
           <a:p>
             <a:pPr lvl="2"/>
@@ -607,6 +615,7 @@
               <a:rPr lang="en-US" smtClean="0"/>
               <a:t>Third level</a:t>
             </a:r>
+            <a:endParaRPr lang="en-US" smtClean="0"/>
           </a:p>
           <a:p>
             <a:pPr lvl="3"/>
@@ -614,6 +623,7 @@
               <a:rPr lang="en-US" smtClean="0"/>
               <a:t>Fourth level</a:t>
             </a:r>
+            <a:endParaRPr lang="en-US" smtClean="0"/>
           </a:p>
           <a:p>
             <a:pPr lvl="4"/>
@@ -642,7 +652,6 @@
           <a:p>
             <a:fld id="{5BCAD085-E8A6-8845-BD4E-CB4CCA059FC4}" type="datetimeFigureOut">
               <a:rPr lang="en-US" smtClean="0"/>
-              <a:t>1/27/13</a:t>
             </a:fld>
             <a:endParaRPr lang="en-US"/>
           </a:p>
@@ -684,18 +693,12 @@
           <a:p>
             <a:fld id="{C1FF6DA9-008F-8B48-92A6-B652298478BF}" type="slidenum">
               <a:rPr lang="en-US" smtClean="0"/>
-              <a:t>‹#›</a:t>
             </a:fld>
             <a:endParaRPr lang="en-US"/>
           </a:p>
         </p:txBody>
       </p:sp>
     </p:spTree>
-    <p:extLst>
-      <p:ext uri="{BB962C8B-B14F-4D97-AF65-F5344CB8AC3E}">
-        <p14:creationId xmlns:p14="http://schemas.microsoft.com/office/powerpoint/2010/main" val="3612223792"/>
-      </p:ext>
-    </p:extLst>
   </p:cSld>
   <p:clrMapOvr>
     <a:masterClrMapping/>
@@ -763,6 +766,7 @@
               <a:rPr lang="en-US" smtClean="0"/>
               <a:t>Click to edit Master text styles</a:t>
             </a:r>
+            <a:endParaRPr lang="en-US" smtClean="0"/>
           </a:p>
           <a:p>
             <a:pPr lvl="1"/>
@@ -770,6 +774,7 @@
               <a:rPr lang="en-US" smtClean="0"/>
               <a:t>Second level</a:t>
             </a:r>
+            <a:endParaRPr lang="en-US" smtClean="0"/>
           </a:p>
           <a:p>
             <a:pPr lvl="2"/>
@@ -777,6 +782,7 @@
               <a:rPr lang="en-US" smtClean="0"/>
               <a:t>Third level</a:t>
             </a:r>
+            <a:endParaRPr lang="en-US" smtClean="0"/>
           </a:p>
           <a:p>
             <a:pPr lvl="3"/>
@@ -784,6 +790,7 @@
               <a:rPr lang="en-US" smtClean="0"/>
               <a:t>Fourth level</a:t>
             </a:r>
+            <a:endParaRPr lang="en-US" smtClean="0"/>
           </a:p>
           <a:p>
             <a:pPr lvl="4"/>
@@ -812,7 +819,6 @@
           <a:p>
             <a:fld id="{5BCAD085-E8A6-8845-BD4E-CB4CCA059FC4}" type="datetimeFigureOut">
               <a:rPr lang="en-US" smtClean="0"/>
-              <a:t>1/27/13</a:t>
             </a:fld>
             <a:endParaRPr lang="en-US"/>
           </a:p>
@@ -854,18 +860,12 @@
           <a:p>
             <a:fld id="{C1FF6DA9-008F-8B48-92A6-B652298478BF}" type="slidenum">
               <a:rPr lang="en-US" smtClean="0"/>
-              <a:t>‹#›</a:t>
             </a:fld>
             <a:endParaRPr lang="en-US"/>
           </a:p>
         </p:txBody>
       </p:sp>
     </p:spTree>
-    <p:extLst>
-      <p:ext uri="{BB962C8B-B14F-4D97-AF65-F5344CB8AC3E}">
-        <p14:creationId xmlns:p14="http://schemas.microsoft.com/office/powerpoint/2010/main" val="2614314258"/>
-      </p:ext>
-    </p:extLst>
   </p:cSld>
   <p:clrMapOvr>
     <a:masterClrMapping/>
@@ -1038,6 +1038,7 @@
               <a:rPr lang="en-US" smtClean="0"/>
               <a:t>Click to edit Master text styles</a:t>
             </a:r>
+            <a:endParaRPr lang="en-US" smtClean="0"/>
           </a:p>
         </p:txBody>
       </p:sp>
@@ -1058,7 +1059,6 @@
           <a:p>
             <a:fld id="{5BCAD085-E8A6-8845-BD4E-CB4CCA059FC4}" type="datetimeFigureOut">
               <a:rPr lang="en-US" smtClean="0"/>
-              <a:t>1/27/13</a:t>
             </a:fld>
             <a:endParaRPr lang="en-US"/>
           </a:p>
@@ -1100,18 +1100,12 @@
           <a:p>
             <a:fld id="{C1FF6DA9-008F-8B48-92A6-B652298478BF}" type="slidenum">
               <a:rPr lang="en-US" smtClean="0"/>
-              <a:t>‹#›</a:t>
             </a:fld>
             <a:endParaRPr lang="en-US"/>
           </a:p>
         </p:txBody>
       </p:sp>
     </p:spTree>
-    <p:extLst>
-      <p:ext uri="{BB962C8B-B14F-4D97-AF65-F5344CB8AC3E}">
-        <p14:creationId xmlns:p14="http://schemas.microsoft.com/office/powerpoint/2010/main" val="960648375"/>
-      </p:ext>
-    </p:extLst>
   </p:cSld>
   <p:clrMapOvr>
     <a:masterClrMapping/>
@@ -1212,6 +1206,7 @@
               <a:rPr lang="en-US" smtClean="0"/>
               <a:t>Click to edit Master text styles</a:t>
             </a:r>
+            <a:endParaRPr lang="en-US" smtClean="0"/>
           </a:p>
           <a:p>
             <a:pPr lvl="1"/>
@@ -1219,6 +1214,7 @@
               <a:rPr lang="en-US" smtClean="0"/>
               <a:t>Second level</a:t>
             </a:r>
+            <a:endParaRPr lang="en-US" smtClean="0"/>
           </a:p>
           <a:p>
             <a:pPr lvl="2"/>
@@ -1226,6 +1222,7 @@
               <a:rPr lang="en-US" smtClean="0"/>
               <a:t>Third level</a:t>
             </a:r>
+            <a:endParaRPr lang="en-US" smtClean="0"/>
           </a:p>
           <a:p>
             <a:pPr lvl="3"/>
@@ -1233,6 +1230,7 @@
               <a:rPr lang="en-US" smtClean="0"/>
               <a:t>Fourth level</a:t>
             </a:r>
+            <a:endParaRPr lang="en-US" smtClean="0"/>
           </a:p>
           <a:p>
             <a:pPr lvl="4"/>
@@ -1297,6 +1295,7 @@
               <a:rPr lang="en-US" smtClean="0"/>
               <a:t>Click to edit Master text styles</a:t>
             </a:r>
+            <a:endParaRPr lang="en-US" smtClean="0"/>
           </a:p>
           <a:p>
             <a:pPr lvl="1"/>
@@ -1304,6 +1303,7 @@
               <a:rPr lang="en-US" smtClean="0"/>
               <a:t>Second level</a:t>
             </a:r>
+            <a:endParaRPr lang="en-US" smtClean="0"/>
           </a:p>
           <a:p>
             <a:pPr lvl="2"/>
@@ -1311,6 +1311,7 @@
               <a:rPr lang="en-US" smtClean="0"/>
               <a:t>Third level</a:t>
             </a:r>
+            <a:endParaRPr lang="en-US" smtClean="0"/>
           </a:p>
           <a:p>
             <a:pPr lvl="3"/>
@@ -1318,6 +1319,7 @@
               <a:rPr lang="en-US" smtClean="0"/>
               <a:t>Fourth level</a:t>
             </a:r>
+            <a:endParaRPr lang="en-US" smtClean="0"/>
           </a:p>
           <a:p>
             <a:pPr lvl="4"/>
@@ -1346,7 +1348,6 @@
           <a:p>
             <a:fld id="{5BCAD085-E8A6-8845-BD4E-CB4CCA059FC4}" type="datetimeFigureOut">
               <a:rPr lang="en-US" smtClean="0"/>
-              <a:t>1/27/13</a:t>
             </a:fld>
             <a:endParaRPr lang="en-US"/>
           </a:p>
@@ -1388,18 +1389,12 @@
           <a:p>
             <a:fld id="{C1FF6DA9-008F-8B48-92A6-B652298478BF}" type="slidenum">
               <a:rPr lang="en-US" smtClean="0"/>
-              <a:t>‹#›</a:t>
             </a:fld>
             <a:endParaRPr lang="en-US"/>
           </a:p>
         </p:txBody>
       </p:sp>
     </p:spTree>
-    <p:extLst>
-      <p:ext uri="{BB962C8B-B14F-4D97-AF65-F5344CB8AC3E}">
-        <p14:creationId xmlns:p14="http://schemas.microsoft.com/office/powerpoint/2010/main" val="2782244947"/>
-      </p:ext>
-    </p:extLst>
   </p:cSld>
   <p:clrMapOvr>
     <a:masterClrMapping/>
@@ -1513,6 +1508,7 @@
               <a:rPr lang="en-US" smtClean="0"/>
               <a:t>Click to edit Master text styles</a:t>
             </a:r>
+            <a:endParaRPr lang="en-US" smtClean="0"/>
           </a:p>
         </p:txBody>
       </p:sp>
@@ -1569,6 +1565,7 @@
               <a:rPr lang="en-US" smtClean="0"/>
               <a:t>Click to edit Master text styles</a:t>
             </a:r>
+            <a:endParaRPr lang="en-US" smtClean="0"/>
           </a:p>
           <a:p>
             <a:pPr lvl="1"/>
@@ -1576,6 +1573,7 @@
               <a:rPr lang="en-US" smtClean="0"/>
               <a:t>Second level</a:t>
             </a:r>
+            <a:endParaRPr lang="en-US" smtClean="0"/>
           </a:p>
           <a:p>
             <a:pPr lvl="2"/>
@@ -1583,6 +1581,7 @@
               <a:rPr lang="en-US" smtClean="0"/>
               <a:t>Third level</a:t>
             </a:r>
+            <a:endParaRPr lang="en-US" smtClean="0"/>
           </a:p>
           <a:p>
             <a:pPr lvl="3"/>
@@ -1590,6 +1589,7 @@
               <a:rPr lang="en-US" smtClean="0"/>
               <a:t>Fourth level</a:t>
             </a:r>
+            <a:endParaRPr lang="en-US" smtClean="0"/>
           </a:p>
           <a:p>
             <a:pPr lvl="4"/>
@@ -1663,6 +1663,7 @@
               <a:rPr lang="en-US" smtClean="0"/>
               <a:t>Click to edit Master text styles</a:t>
             </a:r>
+            <a:endParaRPr lang="en-US" smtClean="0"/>
           </a:p>
         </p:txBody>
       </p:sp>
@@ -1719,6 +1720,7 @@
               <a:rPr lang="en-US" smtClean="0"/>
               <a:t>Click to edit Master text styles</a:t>
             </a:r>
+            <a:endParaRPr lang="en-US" smtClean="0"/>
           </a:p>
           <a:p>
             <a:pPr lvl="1"/>
@@ -1726,6 +1728,7 @@
               <a:rPr lang="en-US" smtClean="0"/>
               <a:t>Second level</a:t>
             </a:r>
+            <a:endParaRPr lang="en-US" smtClean="0"/>
           </a:p>
           <a:p>
             <a:pPr lvl="2"/>
@@ -1733,6 +1736,7 @@
               <a:rPr lang="en-US" smtClean="0"/>
               <a:t>Third level</a:t>
             </a:r>
+            <a:endParaRPr lang="en-US" smtClean="0"/>
           </a:p>
           <a:p>
             <a:pPr lvl="3"/>
@@ -1740,6 +1744,7 @@
               <a:rPr lang="en-US" smtClean="0"/>
               <a:t>Fourth level</a:t>
             </a:r>
+            <a:endParaRPr lang="en-US" smtClean="0"/>
           </a:p>
           <a:p>
             <a:pPr lvl="4"/>
@@ -1768,7 +1773,6 @@
           <a:p>
             <a:fld id="{5BCAD085-E8A6-8845-BD4E-CB4CCA059FC4}" type="datetimeFigureOut">
               <a:rPr lang="en-US" smtClean="0"/>
-              <a:t>1/27/13</a:t>
             </a:fld>
             <a:endParaRPr lang="en-US"/>
           </a:p>
@@ -1810,18 +1814,12 @@
           <a:p>
             <a:fld id="{C1FF6DA9-008F-8B48-92A6-B652298478BF}" type="slidenum">
               <a:rPr lang="en-US" smtClean="0"/>
-              <a:t>‹#›</a:t>
             </a:fld>
             <a:endParaRPr lang="en-US"/>
           </a:p>
         </p:txBody>
       </p:sp>
     </p:spTree>
-    <p:extLst>
-      <p:ext uri="{BB962C8B-B14F-4D97-AF65-F5344CB8AC3E}">
-        <p14:creationId xmlns:p14="http://schemas.microsoft.com/office/powerpoint/2010/main" val="990158736"/>
-      </p:ext>
-    </p:extLst>
   </p:cSld>
   <p:clrMapOvr>
     <a:masterClrMapping/>
@@ -1886,7 +1884,6 @@
           <a:p>
             <a:fld id="{5BCAD085-E8A6-8845-BD4E-CB4CCA059FC4}" type="datetimeFigureOut">
               <a:rPr lang="en-US" smtClean="0"/>
-              <a:t>1/27/13</a:t>
             </a:fld>
             <a:endParaRPr lang="en-US"/>
           </a:p>
@@ -1928,18 +1925,12 @@
           <a:p>
             <a:fld id="{C1FF6DA9-008F-8B48-92A6-B652298478BF}" type="slidenum">
               <a:rPr lang="en-US" smtClean="0"/>
-              <a:t>‹#›</a:t>
             </a:fld>
             <a:endParaRPr lang="en-US"/>
           </a:p>
         </p:txBody>
       </p:sp>
     </p:spTree>
-    <p:extLst>
-      <p:ext uri="{BB962C8B-B14F-4D97-AF65-F5344CB8AC3E}">
-        <p14:creationId xmlns:p14="http://schemas.microsoft.com/office/powerpoint/2010/main" val="727027711"/>
-      </p:ext>
-    </p:extLst>
   </p:cSld>
   <p:clrMapOvr>
     <a:masterClrMapping/>
@@ -1981,7 +1972,6 @@
           <a:p>
             <a:fld id="{5BCAD085-E8A6-8845-BD4E-CB4CCA059FC4}" type="datetimeFigureOut">
               <a:rPr lang="en-US" smtClean="0"/>
-              <a:t>1/27/13</a:t>
             </a:fld>
             <a:endParaRPr lang="en-US"/>
           </a:p>
@@ -2023,18 +2013,12 @@
           <a:p>
             <a:fld id="{C1FF6DA9-008F-8B48-92A6-B652298478BF}" type="slidenum">
               <a:rPr lang="en-US" smtClean="0"/>
-              <a:t>‹#›</a:t>
             </a:fld>
             <a:endParaRPr lang="en-US"/>
           </a:p>
         </p:txBody>
       </p:sp>
     </p:spTree>
-    <p:extLst>
-      <p:ext uri="{BB962C8B-B14F-4D97-AF65-F5344CB8AC3E}">
-        <p14:creationId xmlns:p14="http://schemas.microsoft.com/office/powerpoint/2010/main" val="1212999818"/>
-      </p:ext>
-    </p:extLst>
   </p:cSld>
   <p:clrMapOvr>
     <a:masterClrMapping/>
@@ -2144,6 +2128,7 @@
               <a:rPr lang="en-US" smtClean="0"/>
               <a:t>Click to edit Master text styles</a:t>
             </a:r>
+            <a:endParaRPr lang="en-US" smtClean="0"/>
           </a:p>
           <a:p>
             <a:pPr lvl="1"/>
@@ -2151,6 +2136,7 @@
               <a:rPr lang="en-US" smtClean="0"/>
               <a:t>Second level</a:t>
             </a:r>
+            <a:endParaRPr lang="en-US" smtClean="0"/>
           </a:p>
           <a:p>
             <a:pPr lvl="2"/>
@@ -2158,6 +2144,7 @@
               <a:rPr lang="en-US" smtClean="0"/>
               <a:t>Third level</a:t>
             </a:r>
+            <a:endParaRPr lang="en-US" smtClean="0"/>
           </a:p>
           <a:p>
             <a:pPr lvl="3"/>
@@ -2165,6 +2152,7 @@
               <a:rPr lang="en-US" smtClean="0"/>
               <a:t>Fourth level</a:t>
             </a:r>
+            <a:endParaRPr lang="en-US" smtClean="0"/>
           </a:p>
           <a:p>
             <a:pPr lvl="4"/>
@@ -2238,6 +2226,7 @@
               <a:rPr lang="en-US" smtClean="0"/>
               <a:t>Click to edit Master text styles</a:t>
             </a:r>
+            <a:endParaRPr lang="en-US" smtClean="0"/>
           </a:p>
         </p:txBody>
       </p:sp>
@@ -2258,7 +2247,6 @@
           <a:p>
             <a:fld id="{5BCAD085-E8A6-8845-BD4E-CB4CCA059FC4}" type="datetimeFigureOut">
               <a:rPr lang="en-US" smtClean="0"/>
-              <a:t>1/27/13</a:t>
             </a:fld>
             <a:endParaRPr lang="en-US"/>
           </a:p>
@@ -2300,18 +2288,12 @@
           <a:p>
             <a:fld id="{C1FF6DA9-008F-8B48-92A6-B652298478BF}" type="slidenum">
               <a:rPr lang="en-US" smtClean="0"/>
-              <a:t>‹#›</a:t>
             </a:fld>
             <a:endParaRPr lang="en-US"/>
           </a:p>
         </p:txBody>
       </p:sp>
     </p:spTree>
-    <p:extLst>
-      <p:ext uri="{BB962C8B-B14F-4D97-AF65-F5344CB8AC3E}">
-        <p14:creationId xmlns:p14="http://schemas.microsoft.com/office/powerpoint/2010/main" val="1840726560"/>
-      </p:ext>
-    </p:extLst>
   </p:cSld>
   <p:clrMapOvr>
     <a:masterClrMapping/>
@@ -2491,6 +2473,7 @@
               <a:rPr lang="en-US" smtClean="0"/>
               <a:t>Click to edit Master text styles</a:t>
             </a:r>
+            <a:endParaRPr lang="en-US" smtClean="0"/>
           </a:p>
         </p:txBody>
       </p:sp>
@@ -2511,7 +2494,6 @@
           <a:p>
             <a:fld id="{5BCAD085-E8A6-8845-BD4E-CB4CCA059FC4}" type="datetimeFigureOut">
               <a:rPr lang="en-US" smtClean="0"/>
-              <a:t>1/27/13</a:t>
             </a:fld>
             <a:endParaRPr lang="en-US"/>
           </a:p>
@@ -2553,18 +2535,12 @@
           <a:p>
             <a:fld id="{C1FF6DA9-008F-8B48-92A6-B652298478BF}" type="slidenum">
               <a:rPr lang="en-US" smtClean="0"/>
-              <a:t>‹#›</a:t>
             </a:fld>
             <a:endParaRPr lang="en-US"/>
           </a:p>
         </p:txBody>
       </p:sp>
     </p:spTree>
-    <p:extLst>
-      <p:ext uri="{BB962C8B-B14F-4D97-AF65-F5344CB8AC3E}">
-        <p14:creationId xmlns:p14="http://schemas.microsoft.com/office/powerpoint/2010/main" val="3889236939"/>
-      </p:ext>
-    </p:extLst>
   </p:cSld>
   <p:clrMapOvr>
     <a:masterClrMapping/>
@@ -2657,6 +2633,7 @@
               <a:rPr lang="en-US" smtClean="0"/>
               <a:t>Click to edit Master text styles</a:t>
             </a:r>
+            <a:endParaRPr lang="en-US" smtClean="0"/>
           </a:p>
           <a:p>
             <a:pPr lvl="1"/>
@@ -2664,6 +2641,7 @@
               <a:rPr lang="en-US" smtClean="0"/>
               <a:t>Second level</a:t>
             </a:r>
+            <a:endParaRPr lang="en-US" smtClean="0"/>
           </a:p>
           <a:p>
             <a:pPr lvl="2"/>
@@ -2671,6 +2649,7 @@
               <a:rPr lang="en-US" smtClean="0"/>
               <a:t>Third level</a:t>
             </a:r>
+            <a:endParaRPr lang="en-US" smtClean="0"/>
           </a:p>
           <a:p>
             <a:pPr lvl="3"/>
@@ -2678,6 +2657,7 @@
               <a:rPr lang="en-US" smtClean="0"/>
               <a:t>Fourth level</a:t>
             </a:r>
+            <a:endParaRPr lang="en-US" smtClean="0"/>
           </a:p>
           <a:p>
             <a:pPr lvl="4"/>
@@ -2724,7 +2704,6 @@
           <a:p>
             <a:fld id="{5BCAD085-E8A6-8845-BD4E-CB4CCA059FC4}" type="datetimeFigureOut">
               <a:rPr lang="en-US" smtClean="0"/>
-              <a:t>1/27/13</a:t>
             </a:fld>
             <a:endParaRPr lang="en-US"/>
           </a:p>
@@ -2802,18 +2781,12 @@
           <a:p>
             <a:fld id="{C1FF6DA9-008F-8B48-92A6-B652298478BF}" type="slidenum">
               <a:rPr lang="en-US" smtClean="0"/>
-              <a:t>‹#›</a:t>
             </a:fld>
             <a:endParaRPr lang="en-US"/>
           </a:p>
         </p:txBody>
       </p:sp>
     </p:spTree>
-    <p:extLst>
-      <p:ext uri="{BB962C8B-B14F-4D97-AF65-F5344CB8AC3E}">
-        <p14:creationId xmlns:p14="http://schemas.microsoft.com/office/powerpoint/2010/main" val="2209977519"/>
-      </p:ext>
-    </p:extLst>
   </p:cSld>
   <p:clrMap bg1="lt1" tx1="dk1" bg2="lt2" tx2="dk2" accent1="accent1" accent2="accent2" accent3="accent3" accent4="accent4" accent5="accent5" accent6="accent6" hlink="hlink" folHlink="folHlink"/>
   <p:sldLayoutIdLst>
@@ -2851,7 +2824,7 @@
         <a:spcBef>
           <a:spcPct val="20000"/>
         </a:spcBef>
-        <a:buFont typeface="Arial"/>
+        <a:buFont typeface="Arial" panose="020B0604020202020204"/>
         <a:buChar char="•"/>
         <a:defRPr sz="3200" kern="1200">
           <a:solidFill>
@@ -2866,7 +2839,7 @@
         <a:spcBef>
           <a:spcPct val="20000"/>
         </a:spcBef>
-        <a:buFont typeface="Arial"/>
+        <a:buFont typeface="Arial" panose="020B0604020202020204"/>
         <a:buChar char="–"/>
         <a:defRPr sz="2800" kern="1200">
           <a:solidFill>
@@ -2881,7 +2854,7 @@
         <a:spcBef>
           <a:spcPct val="20000"/>
         </a:spcBef>
-        <a:buFont typeface="Arial"/>
+        <a:buFont typeface="Arial" panose="020B0604020202020204"/>
         <a:buChar char="•"/>
         <a:defRPr sz="2400" kern="1200">
           <a:solidFill>
@@ -2896,7 +2869,7 @@
         <a:spcBef>
           <a:spcPct val="20000"/>
         </a:spcBef>
-        <a:buFont typeface="Arial"/>
+        <a:buFont typeface="Arial" panose="020B0604020202020204"/>
         <a:buChar char="–"/>
         <a:defRPr sz="2000" kern="1200">
           <a:solidFill>
@@ -2911,7 +2884,7 @@
         <a:spcBef>
           <a:spcPct val="20000"/>
         </a:spcBef>
-        <a:buFont typeface="Arial"/>
+        <a:buFont typeface="Arial" panose="020B0604020202020204"/>
         <a:buChar char="»"/>
         <a:defRPr sz="2000" kern="1200">
           <a:solidFill>
@@ -2926,7 +2899,7 @@
         <a:spcBef>
           <a:spcPct val="20000"/>
         </a:spcBef>
-        <a:buFont typeface="Arial"/>
+        <a:buFont typeface="Arial" panose="020B0604020202020204"/>
         <a:buChar char="•"/>
         <a:defRPr sz="2000" kern="1200">
           <a:solidFill>
@@ -2941,7 +2914,7 @@
         <a:spcBef>
           <a:spcPct val="20000"/>
         </a:spcBef>
-        <a:buFont typeface="Arial"/>
+        <a:buFont typeface="Arial" panose="020B0604020202020204"/>
         <a:buChar char="•"/>
         <a:defRPr sz="2000" kern="1200">
           <a:solidFill>
@@ -2956,7 +2929,7 @@
         <a:spcBef>
           <a:spcPct val="20000"/>
         </a:spcBef>
-        <a:buFont typeface="Arial"/>
+        <a:buFont typeface="Arial" panose="020B0604020202020204"/>
         <a:buChar char="•"/>
         <a:defRPr sz="2000" kern="1200">
           <a:solidFill>
@@ -2971,7 +2944,7 @@
         <a:spcBef>
           <a:spcPct val="20000"/>
         </a:spcBef>
-        <a:buFont typeface="Arial"/>
+        <a:buFont typeface="Arial" panose="020B0604020202020204"/>
         <a:buChar char="•"/>
         <a:defRPr sz="2000" kern="1200">
           <a:solidFill>
@@ -3083,7 +3056,7 @@
 </file>
 
 <file path=ppt/slides/slide1.xml><?xml version="1.0" encoding="utf-8"?>
-<p:sld xmlns:a="http://schemas.openxmlformats.org/drawingml/2006/main" xmlns:p="http://schemas.openxmlformats.org/presentationml/2006/main" xmlns:r="http://schemas.openxmlformats.org/officeDocument/2006/relationships">
+<p:sld xmlns:a="http://schemas.openxmlformats.org/drawingml/2006/main" xmlns:r="http://schemas.openxmlformats.org/officeDocument/2006/relationships" xmlns:p="http://schemas.openxmlformats.org/presentationml/2006/main">
   <p:cSld>
     <p:spTree>
       <p:nvGrpSpPr>
@@ -3197,7 +3170,7 @@
           <a:noFill/>
         </p:spPr>
         <p:txBody>
-          <a:bodyPr wrap="square" lIns="0" rIns="0" tIns="0" bIns="0" anchor="t"/>
+          <a:bodyPr wrap="square" lIns="0" tIns="0" rIns="0" bIns="0" anchor="t"/>
           <a:lstStyle/>
           <a:p>
             <a:pPr algn="l">
@@ -3219,6 +3192,14 @@
               </a:rPr>
               <a:t>139788  ·  STEP 3</a:t>
             </a:r>
+            <a:endParaRPr sz="1600" b="1">
+              <a:solidFill>
+                <a:srgbClr val="A8DADC"/>
+              </a:solidFill>
+              <a:latin typeface="DejaVu Sans"/>
+              <a:ea typeface="DejaVu Sans"/>
+              <a:cs typeface="DejaVu Sans"/>
+            </a:endParaRPr>
           </a:p>
         </p:txBody>
       </p:sp>
@@ -3239,7 +3220,7 @@
           <a:noFill/>
         </p:spPr>
         <p:txBody>
-          <a:bodyPr wrap="square" lIns="0" rIns="0" tIns="0" bIns="0" anchor="t"/>
+          <a:bodyPr wrap="square" lIns="0" tIns="0" rIns="0" bIns="0" anchor="t"/>
           <a:lstStyle/>
           <a:p>
             <a:pPr algn="l">
@@ -3261,6 +3242,14 @@
               </a:rPr>
               <a:t>Dead-leg and hold-up retrofit</a:t>
             </a:r>
+            <a:endParaRPr sz="4000" b="1">
+              <a:solidFill>
+                <a:srgbClr val="FFFFFF"/>
+              </a:solidFill>
+              <a:latin typeface="DejaVu Sans"/>
+              <a:ea typeface="DejaVu Sans"/>
+              <a:cs typeface="DejaVu Sans"/>
+            </a:endParaRPr>
           </a:p>
         </p:txBody>
       </p:sp>
@@ -3281,7 +3270,7 @@
           <a:noFill/>
         </p:spPr>
         <p:txBody>
-          <a:bodyPr wrap="square" lIns="0" rIns="0" tIns="0" bIns="0" anchor="t"/>
+          <a:bodyPr wrap="square" lIns="0" tIns="0" rIns="0" bIns="0" anchor="t"/>
           <a:lstStyle/>
           <a:p>
             <a:pPr algn="l">
@@ -3303,6 +3292,14 @@
               </a:rPr>
               <a:t>Schedule for the three options, and where each one applies.</a:t>
             </a:r>
+            <a:endParaRPr sz="1800" b="0">
+              <a:solidFill>
+                <a:srgbClr val="F1FAEE"/>
+              </a:solidFill>
+              <a:latin typeface="DejaVu Sans"/>
+              <a:ea typeface="DejaVu Sans"/>
+              <a:cs typeface="DejaVu Sans"/>
+            </a:endParaRPr>
           </a:p>
         </p:txBody>
       </p:sp>
@@ -3323,7 +3320,7 @@
           <a:noFill/>
         </p:spPr>
         <p:txBody>
-          <a:bodyPr wrap="square" lIns="0" rIns="0" tIns="0" bIns="0" anchor="t"/>
+          <a:bodyPr wrap="square" lIns="0" tIns="0" rIns="0" bIns="0" anchor="t"/>
           <a:lstStyle/>
           <a:p>
             <a:pPr algn="l">
@@ -3345,6 +3342,14 @@
               </a:rPr>
               <a:t>Asymchem   ·   Client review   ·   October 2026</a:t>
             </a:r>
+            <a:endParaRPr sz="1400" b="0">
+              <a:solidFill>
+                <a:srgbClr val="A8DADC"/>
+              </a:solidFill>
+              <a:latin typeface="DejaVu Sans"/>
+              <a:ea typeface="DejaVu Sans"/>
+              <a:cs typeface="DejaVu Sans"/>
+            </a:endParaRPr>
           </a:p>
         </p:txBody>
       </p:sp>
@@ -3357,7 +3362,7 @@
 </file>
 
 <file path=ppt/slides/slide2.xml><?xml version="1.0" encoding="utf-8"?>
-<p:sld xmlns:a="http://schemas.openxmlformats.org/drawingml/2006/main" xmlns:p="http://schemas.openxmlformats.org/presentationml/2006/main" xmlns:r="http://schemas.openxmlformats.org/officeDocument/2006/relationships">
+<p:sld xmlns:a="http://schemas.openxmlformats.org/drawingml/2006/main" xmlns:r="http://schemas.openxmlformats.org/officeDocument/2006/relationships" xmlns:p="http://schemas.openxmlformats.org/presentationml/2006/main">
   <p:cSld>
     <p:spTree>
       <p:nvGrpSpPr>
@@ -3462,8 +3467,8 @@
         </p:nvSpPr>
         <p:spPr>
           <a:xfrm>
-            <a:off x="502920" y="256032"/>
-            <a:ext cx="11155680" cy="868680"/>
+            <a:off x="226695" y="589915"/>
+            <a:ext cx="11739245" cy="584200"/>
           </a:xfrm>
           <a:prstGeom prst="rect">
             <a:avLst/>
@@ -3471,7 +3476,7 @@
           <a:noFill/>
         </p:spPr>
         <p:txBody>
-          <a:bodyPr wrap="square" lIns="0" rIns="0" tIns="0" bIns="0" anchor="t"/>
+          <a:bodyPr wrap="square" lIns="0" tIns="0" rIns="0" bIns="0" anchor="t"/>
           <a:lstStyle/>
           <a:p>
             <a:pPr algn="l">
@@ -3483,7 +3488,7 @@
               </a:spcAft>
             </a:pPr>
             <a:r>
-              <a:rPr sz="2600" b="1">
+              <a:rPr sz="2400" b="1">
                 <a:solidFill>
                   <a:srgbClr val="1A2332"/>
                 </a:solidFill>
@@ -3493,48 +3498,54 @@
               </a:rPr>
               <a:t>Demo uses Option 1. Pre-PPQ and PPQ use Option 2.</a:t>
             </a:r>
-          </a:p>
-        </p:txBody>
-      </p:sp>
-      <p:sp>
-        <p:nvSpPr>
-          <p:cNvPr id="5" name="TextBox 4"/>
-          <p:cNvSpPr txBox="1"/>
-          <p:nvPr/>
-        </p:nvSpPr>
-        <p:spPr>
-          <a:xfrm>
-            <a:off x="502920" y="1143000"/>
-            <a:ext cx="10972800" cy="320040"/>
-          </a:xfrm>
-          <a:prstGeom prst="rect">
-            <a:avLst/>
-          </a:prstGeom>
-          <a:noFill/>
-        </p:spPr>
-        <p:txBody>
-          <a:bodyPr wrap="square" lIns="0" rIns="0" tIns="0" bIns="0" anchor="t"/>
-          <a:lstStyle/>
-          <a:p>
-            <a:pPr algn="l">
-              <a:spcBef>
-                <a:spcPts val="0"/>
-              </a:spcBef>
-              <a:spcAft>
-                <a:spcPts val="0"/>
-              </a:spcAft>
-            </a:pPr>
-            <a:r>
-              <a:rPr sz="1500" b="0">
+            <a:r>
+              <a:rPr lang="en-US" sz="2400" b="1">
                 <a:solidFill>
-                  <a:srgbClr val="5D6D7E"/>
+                  <a:srgbClr val="1A2332"/>
                 </a:solidFill>
                 <a:latin typeface="DejaVu Sans"/>
                 <a:ea typeface="DejaVu Sans"/>
                 <a:cs typeface="DejaVu Sans"/>
               </a:rPr>
-              <a:t>Commercial manufacture uses Option 3. All four steps handle process material.</a:t>
-            </a:r>
+              <a:t> </a:t>
+            </a:r>
+            <a:r>
+              <a:rPr lang="en-US" altLang="en-US" sz="2400" b="1">
+                <a:solidFill>
+                  <a:srgbClr val="1A2332"/>
+                </a:solidFill>
+                <a:latin typeface="DejaVu Sans"/>
+                <a:ea typeface="DejaVu Sans"/>
+                <a:cs typeface="DejaVu Sans"/>
+              </a:rPr>
+              <a:t>Commercial manufacture uses Option 3. </a:t>
+            </a:r>
+            <a:endParaRPr lang="en-US" altLang="en-US" sz="2400" b="1">
+              <a:solidFill>
+                <a:srgbClr val="1A2332"/>
+              </a:solidFill>
+              <a:latin typeface="DejaVu Sans"/>
+              <a:ea typeface="DejaVu Sans"/>
+              <a:cs typeface="DejaVu Sans"/>
+            </a:endParaRPr>
+          </a:p>
+          <a:p>
+            <a:pPr algn="l">
+              <a:spcBef>
+                <a:spcPts val="0"/>
+              </a:spcBef>
+              <a:spcAft>
+                <a:spcPts val="0"/>
+              </a:spcAft>
+            </a:pPr>
+            <a:endParaRPr lang="en-US" altLang="en-US" sz="2400" b="1">
+              <a:solidFill>
+                <a:srgbClr val="1A2332"/>
+              </a:solidFill>
+              <a:latin typeface="DejaVu Sans"/>
+              <a:ea typeface="DejaVu Sans"/>
+              <a:cs typeface="DejaVu Sans"/>
+            </a:endParaRPr>
           </a:p>
         </p:txBody>
       </p:sp>
@@ -3581,9 +3592,17 @@
                         </a:rPr>
                         <a:t>Process step</a:t>
                       </a:r>
+                      <a:endParaRPr sz="1400" b="1">
+                        <a:solidFill>
+                          <a:srgbClr val="FFFFFF"/>
+                        </a:solidFill>
+                        <a:latin typeface="DejaVu Sans"/>
+                        <a:ea typeface="DejaVu Sans"/>
+                        <a:cs typeface="DejaVu Sans"/>
+                      </a:endParaRPr>
                     </a:p>
                   </a:txBody>
-                  <a:tcPr marL="91440" marR="73152" marT="54864" marB="54864" anchor="ctr">
+                  <a:tcPr marR="73152" marT="54864" marB="54864" anchor="ctr">
                     <a:solidFill>
                       <a:srgbClr val="1A2332"/>
                     </a:solidFill>
@@ -3606,9 +3625,17 @@
                         </a:rPr>
                         <a:t>Demo</a:t>
                       </a:r>
+                      <a:endParaRPr sz="1400" b="1">
+                        <a:solidFill>
+                          <a:srgbClr val="FFFFFF"/>
+                        </a:solidFill>
+                        <a:latin typeface="DejaVu Sans"/>
+                        <a:ea typeface="DejaVu Sans"/>
+                        <a:cs typeface="DejaVu Sans"/>
+                      </a:endParaRPr>
                     </a:p>
                   </a:txBody>
-                  <a:tcPr marL="91440" marR="73152" marT="54864" marB="54864" anchor="ctr">
+                  <a:tcPr marR="73152" marT="54864" marB="54864" anchor="ctr">
                     <a:solidFill>
                       <a:srgbClr val="1A2332"/>
                     </a:solidFill>
@@ -3631,9 +3658,17 @@
                         </a:rPr>
                         <a:t>Pre-PPQ</a:t>
                       </a:r>
+                      <a:endParaRPr sz="1400" b="1">
+                        <a:solidFill>
+                          <a:srgbClr val="FFFFFF"/>
+                        </a:solidFill>
+                        <a:latin typeface="DejaVu Sans"/>
+                        <a:ea typeface="DejaVu Sans"/>
+                        <a:cs typeface="DejaVu Sans"/>
+                      </a:endParaRPr>
                     </a:p>
                   </a:txBody>
-                  <a:tcPr marL="91440" marR="73152" marT="54864" marB="54864" anchor="ctr">
+                  <a:tcPr marR="73152" marT="54864" marB="54864" anchor="ctr">
                     <a:solidFill>
                       <a:srgbClr val="1A2332"/>
                     </a:solidFill>
@@ -3656,9 +3691,17 @@
                         </a:rPr>
                         <a:t>PPQ</a:t>
                       </a:r>
+                      <a:endParaRPr sz="1400" b="1">
+                        <a:solidFill>
+                          <a:srgbClr val="FFFFFF"/>
+                        </a:solidFill>
+                        <a:latin typeface="DejaVu Sans"/>
+                        <a:ea typeface="DejaVu Sans"/>
+                        <a:cs typeface="DejaVu Sans"/>
+                      </a:endParaRPr>
                     </a:p>
                   </a:txBody>
-                  <a:tcPr marL="91440" marR="73152" marT="54864" marB="54864" anchor="ctr">
+                  <a:tcPr marR="73152" marT="54864" marB="54864" anchor="ctr">
                     <a:solidFill>
                       <a:srgbClr val="1A2332"/>
                     </a:solidFill>
@@ -3681,9 +3724,17 @@
                         </a:rPr>
                         <a:t>Commercial</a:t>
                       </a:r>
+                      <a:endParaRPr sz="1400" b="1">
+                        <a:solidFill>
+                          <a:srgbClr val="FFFFFF"/>
+                        </a:solidFill>
+                        <a:latin typeface="DejaVu Sans"/>
+                        <a:ea typeface="DejaVu Sans"/>
+                        <a:cs typeface="DejaVu Sans"/>
+                      </a:endParaRPr>
                     </a:p>
                   </a:txBody>
-                  <a:tcPr marL="91440" marR="73152" marT="54864" marB="54864" anchor="ctr">
+                  <a:tcPr marR="73152" marT="54864" marB="54864" anchor="ctr">
                     <a:solidFill>
                       <a:srgbClr val="1A2332"/>
                     </a:solidFill>
@@ -3708,9 +3759,17 @@
                         </a:rPr>
                         <a:t>Preparative buffer preparation</a:t>
                       </a:r>
+                      <a:endParaRPr sz="1600" b="1">
+                        <a:solidFill>
+                          <a:srgbClr val="1A2332"/>
+                        </a:solidFill>
+                        <a:latin typeface="DejaVu Sans"/>
+                        <a:ea typeface="DejaVu Sans"/>
+                        <a:cs typeface="DejaVu Sans"/>
+                      </a:endParaRPr>
                     </a:p>
                   </a:txBody>
-                  <a:tcPr marL="91440" marR="73152" marT="54864" marB="54864" anchor="ctr">
+                  <a:tcPr marR="73152" marT="54864" marB="54864" anchor="ctr">
                     <a:solidFill>
                       <a:srgbClr val="F7FBFB"/>
                     </a:solidFill>
@@ -3733,9 +3792,17 @@
                         </a:rPr>
                         <a:t>Option 1</a:t>
                       </a:r>
+                      <a:endParaRPr sz="1600" b="1">
+                        <a:solidFill>
+                          <a:srgbClr val="2D8B8B"/>
+                        </a:solidFill>
+                        <a:latin typeface="DejaVu Sans"/>
+                        <a:ea typeface="DejaVu Sans"/>
+                        <a:cs typeface="DejaVu Sans"/>
+                      </a:endParaRPr>
                     </a:p>
                   </a:txBody>
-                  <a:tcPr marL="91440" marR="73152" marT="54864" marB="54864" anchor="ctr">
+                  <a:tcPr marR="73152" marT="54864" marB="54864" anchor="ctr">
                     <a:solidFill>
                       <a:srgbClr val="E7F3F3"/>
                     </a:solidFill>
@@ -3758,9 +3825,17 @@
                         </a:rPr>
                         <a:t>Option 2</a:t>
                       </a:r>
+                      <a:endParaRPr sz="1600" b="1">
+                        <a:solidFill>
+                          <a:srgbClr val="1C2833"/>
+                        </a:solidFill>
+                        <a:latin typeface="DejaVu Sans"/>
+                        <a:ea typeface="DejaVu Sans"/>
+                        <a:cs typeface="DejaVu Sans"/>
+                      </a:endParaRPr>
                     </a:p>
                   </a:txBody>
-                  <a:tcPr marL="91440" marR="73152" marT="54864" marB="54864" anchor="ctr">
+                  <a:tcPr marR="73152" marT="54864" marB="54864" anchor="ctr">
                     <a:solidFill>
                       <a:srgbClr val="FFFFFF"/>
                     </a:solidFill>
@@ -3783,9 +3858,17 @@
                         </a:rPr>
                         <a:t>Option 2</a:t>
                       </a:r>
+                      <a:endParaRPr sz="1600" b="1">
+                        <a:solidFill>
+                          <a:srgbClr val="1C2833"/>
+                        </a:solidFill>
+                        <a:latin typeface="DejaVu Sans"/>
+                        <a:ea typeface="DejaVu Sans"/>
+                        <a:cs typeface="DejaVu Sans"/>
+                      </a:endParaRPr>
                     </a:p>
                   </a:txBody>
-                  <a:tcPr marL="91440" marR="73152" marT="54864" marB="54864" anchor="ctr">
+                  <a:tcPr marR="73152" marT="54864" marB="54864" anchor="ctr">
                     <a:solidFill>
                       <a:srgbClr val="FFFFFF"/>
                     </a:solidFill>
@@ -3808,9 +3891,17 @@
                         </a:rPr>
                         <a:t>Option 3</a:t>
                       </a:r>
+                      <a:endParaRPr sz="1600" b="1">
+                        <a:solidFill>
+                          <a:srgbClr val="1F6B4A"/>
+                        </a:solidFill>
+                        <a:latin typeface="DejaVu Sans"/>
+                        <a:ea typeface="DejaVu Sans"/>
+                        <a:cs typeface="DejaVu Sans"/>
+                      </a:endParaRPr>
                     </a:p>
                   </a:txBody>
-                  <a:tcPr marL="91440" marR="73152" marT="54864" marB="54864" anchor="ctr">
+                  <a:tcPr marR="73152" marT="54864" marB="54864" anchor="ctr">
                     <a:solidFill>
                       <a:srgbClr val="E8F2EA"/>
                     </a:solidFill>
@@ -3835,9 +3926,17 @@
                         </a:rPr>
                         <a:t>Preparative chromatography</a:t>
                       </a:r>
+                      <a:endParaRPr sz="1600" b="1">
+                        <a:solidFill>
+                          <a:srgbClr val="1A2332"/>
+                        </a:solidFill>
+                        <a:latin typeface="DejaVu Sans"/>
+                        <a:ea typeface="DejaVu Sans"/>
+                        <a:cs typeface="DejaVu Sans"/>
+                      </a:endParaRPr>
                     </a:p>
                   </a:txBody>
-                  <a:tcPr marL="91440" marR="73152" marT="54864" marB="54864" anchor="ctr">
+                  <a:tcPr marR="73152" marT="54864" marB="54864" anchor="ctr">
                     <a:solidFill>
                       <a:srgbClr val="F7FBFB"/>
                     </a:solidFill>
@@ -3860,9 +3959,17 @@
                         </a:rPr>
                         <a:t>Option 1</a:t>
                       </a:r>
+                      <a:endParaRPr sz="1600" b="1">
+                        <a:solidFill>
+                          <a:srgbClr val="2D8B8B"/>
+                        </a:solidFill>
+                        <a:latin typeface="DejaVu Sans"/>
+                        <a:ea typeface="DejaVu Sans"/>
+                        <a:cs typeface="DejaVu Sans"/>
+                      </a:endParaRPr>
                     </a:p>
                   </a:txBody>
-                  <a:tcPr marL="91440" marR="73152" marT="54864" marB="54864" anchor="ctr">
+                  <a:tcPr marR="73152" marT="54864" marB="54864" anchor="ctr">
                     <a:solidFill>
                       <a:srgbClr val="E7F3F3"/>
                     </a:solidFill>
@@ -3885,9 +3992,17 @@
                         </a:rPr>
                         <a:t>Option 2</a:t>
                       </a:r>
+                      <a:endParaRPr sz="1600" b="1">
+                        <a:solidFill>
+                          <a:srgbClr val="1C2833"/>
+                        </a:solidFill>
+                        <a:latin typeface="DejaVu Sans"/>
+                        <a:ea typeface="DejaVu Sans"/>
+                        <a:cs typeface="DejaVu Sans"/>
+                      </a:endParaRPr>
                     </a:p>
                   </a:txBody>
-                  <a:tcPr marL="91440" marR="73152" marT="54864" marB="54864" anchor="ctr">
+                  <a:tcPr marR="73152" marT="54864" marB="54864" anchor="ctr">
                     <a:solidFill>
                       <a:srgbClr val="FFFFFF"/>
                     </a:solidFill>
@@ -3910,9 +4025,17 @@
                         </a:rPr>
                         <a:t>Option 2</a:t>
                       </a:r>
+                      <a:endParaRPr sz="1600" b="1">
+                        <a:solidFill>
+                          <a:srgbClr val="1C2833"/>
+                        </a:solidFill>
+                        <a:latin typeface="DejaVu Sans"/>
+                        <a:ea typeface="DejaVu Sans"/>
+                        <a:cs typeface="DejaVu Sans"/>
+                      </a:endParaRPr>
                     </a:p>
                   </a:txBody>
-                  <a:tcPr marL="91440" marR="73152" marT="54864" marB="54864" anchor="ctr">
+                  <a:tcPr marR="73152" marT="54864" marB="54864" anchor="ctr">
                     <a:solidFill>
                       <a:srgbClr val="FFFFFF"/>
                     </a:solidFill>
@@ -3935,9 +4058,17 @@
                         </a:rPr>
                         <a:t>Option 3</a:t>
                       </a:r>
+                      <a:endParaRPr sz="1600" b="1">
+                        <a:solidFill>
+                          <a:srgbClr val="1F6B4A"/>
+                        </a:solidFill>
+                        <a:latin typeface="DejaVu Sans"/>
+                        <a:ea typeface="DejaVu Sans"/>
+                        <a:cs typeface="DejaVu Sans"/>
+                      </a:endParaRPr>
                     </a:p>
                   </a:txBody>
-                  <a:tcPr marL="91440" marR="73152" marT="54864" marB="54864" anchor="ctr">
+                  <a:tcPr marR="73152" marT="54864" marB="54864" anchor="ctr">
                     <a:solidFill>
                       <a:srgbClr val="E8F2EA"/>
                     </a:solidFill>
@@ -3962,9 +4093,17 @@
                         </a:rPr>
                         <a:t>TFF</a:t>
                       </a:r>
+                      <a:endParaRPr sz="1600" b="1">
+                        <a:solidFill>
+                          <a:srgbClr val="1A2332"/>
+                        </a:solidFill>
+                        <a:latin typeface="DejaVu Sans"/>
+                        <a:ea typeface="DejaVu Sans"/>
+                        <a:cs typeface="DejaVu Sans"/>
+                      </a:endParaRPr>
                     </a:p>
                   </a:txBody>
-                  <a:tcPr marL="91440" marR="73152" marT="54864" marB="54864" anchor="ctr">
+                  <a:tcPr marR="73152" marT="54864" marB="54864" anchor="ctr">
                     <a:solidFill>
                       <a:srgbClr val="F7FBFB"/>
                     </a:solidFill>
@@ -3987,9 +4126,17 @@
                         </a:rPr>
                         <a:t>Option 1</a:t>
                       </a:r>
+                      <a:endParaRPr sz="1600" b="1">
+                        <a:solidFill>
+                          <a:srgbClr val="2D8B8B"/>
+                        </a:solidFill>
+                        <a:latin typeface="DejaVu Sans"/>
+                        <a:ea typeface="DejaVu Sans"/>
+                        <a:cs typeface="DejaVu Sans"/>
+                      </a:endParaRPr>
                     </a:p>
                   </a:txBody>
-                  <a:tcPr marL="91440" marR="73152" marT="54864" marB="54864" anchor="ctr">
+                  <a:tcPr marR="73152" marT="54864" marB="54864" anchor="ctr">
                     <a:solidFill>
                       <a:srgbClr val="E7F3F3"/>
                     </a:solidFill>
@@ -4012,9 +4159,17 @@
                         </a:rPr>
                         <a:t>Option 2</a:t>
                       </a:r>
+                      <a:endParaRPr sz="1600" b="1">
+                        <a:solidFill>
+                          <a:srgbClr val="1C2833"/>
+                        </a:solidFill>
+                        <a:latin typeface="DejaVu Sans"/>
+                        <a:ea typeface="DejaVu Sans"/>
+                        <a:cs typeface="DejaVu Sans"/>
+                      </a:endParaRPr>
                     </a:p>
                   </a:txBody>
-                  <a:tcPr marL="91440" marR="73152" marT="54864" marB="54864" anchor="ctr">
+                  <a:tcPr marR="73152" marT="54864" marB="54864" anchor="ctr">
                     <a:solidFill>
                       <a:srgbClr val="FFFFFF"/>
                     </a:solidFill>
@@ -4037,9 +4192,17 @@
                         </a:rPr>
                         <a:t>Option 2</a:t>
                       </a:r>
+                      <a:endParaRPr sz="1600" b="1">
+                        <a:solidFill>
+                          <a:srgbClr val="1C2833"/>
+                        </a:solidFill>
+                        <a:latin typeface="DejaVu Sans"/>
+                        <a:ea typeface="DejaVu Sans"/>
+                        <a:cs typeface="DejaVu Sans"/>
+                      </a:endParaRPr>
                     </a:p>
                   </a:txBody>
-                  <a:tcPr marL="91440" marR="73152" marT="54864" marB="54864" anchor="ctr">
+                  <a:tcPr marR="73152" marT="54864" marB="54864" anchor="ctr">
                     <a:solidFill>
                       <a:srgbClr val="FFFFFF"/>
                     </a:solidFill>
@@ -4062,9 +4225,17 @@
                         </a:rPr>
                         <a:t>Option 3</a:t>
                       </a:r>
+                      <a:endParaRPr sz="1600" b="1">
+                        <a:solidFill>
+                          <a:srgbClr val="1F6B4A"/>
+                        </a:solidFill>
+                        <a:latin typeface="DejaVu Sans"/>
+                        <a:ea typeface="DejaVu Sans"/>
+                        <a:cs typeface="DejaVu Sans"/>
+                      </a:endParaRPr>
                     </a:p>
                   </a:txBody>
-                  <a:tcPr marL="91440" marR="73152" marT="54864" marB="54864" anchor="ctr">
+                  <a:tcPr marR="73152" marT="54864" marB="54864" anchor="ctr">
                     <a:solidFill>
                       <a:srgbClr val="E8F2EA"/>
                     </a:solidFill>
@@ -4089,9 +4260,17 @@
                         </a:rPr>
                         <a:t>Precipitation</a:t>
                       </a:r>
+                      <a:endParaRPr sz="1600" b="1">
+                        <a:solidFill>
+                          <a:srgbClr val="1A2332"/>
+                        </a:solidFill>
+                        <a:latin typeface="DejaVu Sans"/>
+                        <a:ea typeface="DejaVu Sans"/>
+                        <a:cs typeface="DejaVu Sans"/>
+                      </a:endParaRPr>
                     </a:p>
                   </a:txBody>
-                  <a:tcPr marL="91440" marR="73152" marT="54864" marB="54864" anchor="ctr">
+                  <a:tcPr marR="73152" marT="54864" marB="54864" anchor="ctr">
                     <a:solidFill>
                       <a:srgbClr val="F7FBFB"/>
                     </a:solidFill>
@@ -4114,9 +4293,17 @@
                         </a:rPr>
                         <a:t>Option 1</a:t>
                       </a:r>
+                      <a:endParaRPr sz="1600" b="1">
+                        <a:solidFill>
+                          <a:srgbClr val="2D8B8B"/>
+                        </a:solidFill>
+                        <a:latin typeface="DejaVu Sans"/>
+                        <a:ea typeface="DejaVu Sans"/>
+                        <a:cs typeface="DejaVu Sans"/>
+                      </a:endParaRPr>
                     </a:p>
                   </a:txBody>
-                  <a:tcPr marL="91440" marR="73152" marT="54864" marB="54864" anchor="ctr">
+                  <a:tcPr marR="73152" marT="54864" marB="54864" anchor="ctr">
                     <a:solidFill>
                       <a:srgbClr val="E7F3F3"/>
                     </a:solidFill>
@@ -4139,9 +4326,17 @@
                         </a:rPr>
                         <a:t>Option 2</a:t>
                       </a:r>
+                      <a:endParaRPr sz="1600" b="1">
+                        <a:solidFill>
+                          <a:srgbClr val="1C2833"/>
+                        </a:solidFill>
+                        <a:latin typeface="DejaVu Sans"/>
+                        <a:ea typeface="DejaVu Sans"/>
+                        <a:cs typeface="DejaVu Sans"/>
+                      </a:endParaRPr>
                     </a:p>
                   </a:txBody>
-                  <a:tcPr marL="91440" marR="73152" marT="54864" marB="54864" anchor="ctr">
+                  <a:tcPr marR="73152" marT="54864" marB="54864" anchor="ctr">
                     <a:solidFill>
                       <a:srgbClr val="FFFFFF"/>
                     </a:solidFill>
@@ -4164,9 +4359,17 @@
                         </a:rPr>
                         <a:t>Option 2</a:t>
                       </a:r>
+                      <a:endParaRPr sz="1600" b="1">
+                        <a:solidFill>
+                          <a:srgbClr val="1C2833"/>
+                        </a:solidFill>
+                        <a:latin typeface="DejaVu Sans"/>
+                        <a:ea typeface="DejaVu Sans"/>
+                        <a:cs typeface="DejaVu Sans"/>
+                      </a:endParaRPr>
                     </a:p>
                   </a:txBody>
-                  <a:tcPr marL="91440" marR="73152" marT="54864" marB="54864" anchor="ctr">
+                  <a:tcPr marR="73152" marT="54864" marB="54864" anchor="ctr">
                     <a:solidFill>
                       <a:srgbClr val="FFFFFF"/>
                     </a:solidFill>
@@ -4189,9 +4392,17 @@
                         </a:rPr>
                         <a:t>Option 3</a:t>
                       </a:r>
+                      <a:endParaRPr sz="1600" b="1">
+                        <a:solidFill>
+                          <a:srgbClr val="1F6B4A"/>
+                        </a:solidFill>
+                        <a:latin typeface="DejaVu Sans"/>
+                        <a:ea typeface="DejaVu Sans"/>
+                        <a:cs typeface="DejaVu Sans"/>
+                      </a:endParaRPr>
                     </a:p>
                   </a:txBody>
-                  <a:tcPr marL="91440" marR="73152" marT="54864" marB="54864" anchor="ctr">
+                  <a:tcPr marR="73152" marT="54864" marB="54864" anchor="ctr">
                     <a:solidFill>
                       <a:srgbClr val="E8F2EA"/>
                     </a:solidFill>
@@ -4219,7 +4430,7 @@
           <a:noFill/>
         </p:spPr>
         <p:txBody>
-          <a:bodyPr wrap="square" lIns="0" rIns="0" tIns="0" bIns="0" anchor="t"/>
+          <a:bodyPr wrap="square" lIns="0" tIns="0" rIns="0" bIns="0" anchor="t"/>
           <a:lstStyle/>
           <a:p>
             <a:pPr algn="l">
@@ -4241,6 +4452,14 @@
               </a:rPr>
               <a:t>139788 Step 3  ·  Dead-leg and hold-up retrofit</a:t>
             </a:r>
+            <a:endParaRPr sz="1100" b="0">
+              <a:solidFill>
+                <a:srgbClr val="5D6D7E"/>
+              </a:solidFill>
+              <a:latin typeface="DejaVu Sans"/>
+              <a:ea typeface="DejaVu Sans"/>
+              <a:cs typeface="DejaVu Sans"/>
+            </a:endParaRPr>
           </a:p>
         </p:txBody>
       </p:sp>
@@ -4261,7 +4480,7 @@
           <a:noFill/>
         </p:spPr>
         <p:txBody>
-          <a:bodyPr wrap="square" lIns="0" rIns="0" tIns="0" bIns="0" anchor="t"/>
+          <a:bodyPr wrap="square" lIns="0" tIns="0" rIns="0" bIns="0" anchor="t"/>
           <a:lstStyle/>
           <a:p>
             <a:pPr algn="r">
@@ -4283,6 +4502,14 @@
               </a:rPr>
               <a:t>2  /  5</a:t>
             </a:r>
+            <a:endParaRPr sz="1100" b="0">
+              <a:solidFill>
+                <a:srgbClr val="5D6D7E"/>
+              </a:solidFill>
+              <a:latin typeface="DejaVu Sans"/>
+              <a:ea typeface="DejaVu Sans"/>
+              <a:cs typeface="DejaVu Sans"/>
+            </a:endParaRPr>
           </a:p>
         </p:txBody>
       </p:sp>
@@ -4295,7 +4522,7 @@
 </file>
 
 <file path=ppt/slides/slide3.xml><?xml version="1.0" encoding="utf-8"?>
-<p:sld xmlns:a="http://schemas.openxmlformats.org/drawingml/2006/main" xmlns:p="http://schemas.openxmlformats.org/presentationml/2006/main" xmlns:r="http://schemas.openxmlformats.org/officeDocument/2006/relationships">
+<p:sld xmlns:a="http://schemas.openxmlformats.org/drawingml/2006/main" xmlns:r="http://schemas.openxmlformats.org/officeDocument/2006/relationships" xmlns:p="http://schemas.openxmlformats.org/presentationml/2006/main">
   <p:cSld>
     <p:spTree>
       <p:nvGrpSpPr>
@@ -4409,7 +4636,7 @@
           <a:noFill/>
         </p:spPr>
         <p:txBody>
-          <a:bodyPr wrap="square" lIns="0" rIns="0" tIns="0" bIns="0" anchor="t"/>
+          <a:bodyPr wrap="square" lIns="0" tIns="0" rIns="0" bIns="0" anchor="t"/>
           <a:lstStyle/>
           <a:p>
             <a:pPr algn="l">
@@ -4431,6 +4658,14 @@
               </a:rPr>
               <a:t>Option 1: procedural control by November 5, 2026.</a:t>
             </a:r>
+            <a:endParaRPr sz="2600" b="1">
+              <a:solidFill>
+                <a:srgbClr val="1A2332"/>
+              </a:solidFill>
+              <a:latin typeface="DejaVu Sans"/>
+              <a:ea typeface="DejaVu Sans"/>
+              <a:cs typeface="DejaVu Sans"/>
+            </a:endParaRPr>
           </a:p>
         </p:txBody>
       </p:sp>
@@ -4451,7 +4686,7 @@
           <a:noFill/>
         </p:spPr>
         <p:txBody>
-          <a:bodyPr wrap="square" lIns="0" rIns="0" tIns="0" bIns="0" anchor="t"/>
+          <a:bodyPr wrap="square" lIns="0" tIns="0" rIns="0" bIns="0" anchor="t"/>
           <a:lstStyle/>
           <a:p>
             <a:pPr algn="l">
@@ -4473,6 +4708,14 @@
               </a:rPr>
               <a:t>The piping stays as it is. The control is how the line is used and cleaned.</a:t>
             </a:r>
+            <a:endParaRPr sz="1500" b="0">
+              <a:solidFill>
+                <a:srgbClr val="5D6D7E"/>
+              </a:solidFill>
+              <a:latin typeface="DejaVu Sans"/>
+              <a:ea typeface="DejaVu Sans"/>
+              <a:cs typeface="DejaVu Sans"/>
+            </a:endParaRPr>
           </a:p>
         </p:txBody>
       </p:sp>
@@ -4539,7 +4782,7 @@
           <a:noFill/>
         </p:spPr>
         <p:txBody>
-          <a:bodyPr wrap="square" lIns="0" rIns="0" tIns="0" bIns="0" anchor="t"/>
+          <a:bodyPr wrap="square" lIns="0" tIns="0" rIns="0" bIns="0" anchor="t"/>
           <a:lstStyle/>
           <a:p>
             <a:pPr algn="l">
@@ -4561,6 +4804,14 @@
               </a:rPr>
               <a:t>POTENTIAL RISK</a:t>
             </a:r>
+            <a:endParaRPr sz="1200" b="1">
+              <a:solidFill>
+                <a:srgbClr val="8C3A3A"/>
+              </a:solidFill>
+              <a:latin typeface="DejaVu Sans"/>
+              <a:ea typeface="DejaVu Sans"/>
+              <a:cs typeface="DejaVu Sans"/>
+            </a:endParaRPr>
           </a:p>
         </p:txBody>
       </p:sp>
@@ -4581,7 +4832,7 @@
           <a:noFill/>
         </p:spPr>
         <p:txBody>
-          <a:bodyPr wrap="square" lIns="0" rIns="0" tIns="0" bIns="0" anchor="t"/>
+          <a:bodyPr wrap="square" lIns="0" tIns="0" rIns="0" bIns="0" anchor="t"/>
           <a:lstStyle/>
           <a:p>
             <a:pPr algn="l">
@@ -4603,6 +4854,14 @@
               </a:rPr>
               <a:t>Hold-up in the piping can degrade the material, support microbial growth, or cause cross-contamination. The flush, drain, purge, and disassembly required after each use are not defined.</a:t>
             </a:r>
+            <a:endParaRPr sz="1500" b="0">
+              <a:solidFill>
+                <a:srgbClr val="1C2833"/>
+              </a:solidFill>
+              <a:latin typeface="DejaVu Sans"/>
+              <a:ea typeface="DejaVu Sans"/>
+              <a:cs typeface="DejaVu Sans"/>
+            </a:endParaRPr>
           </a:p>
         </p:txBody>
       </p:sp>
@@ -4715,7 +4974,7 @@
           <a:noFill/>
         </p:spPr>
         <p:txBody>
-          <a:bodyPr wrap="square" lIns="0" rIns="0" tIns="0" bIns="0" anchor="t"/>
+          <a:bodyPr wrap="square" lIns="0" tIns="0" rIns="0" bIns="0" anchor="t"/>
           <a:lstStyle/>
           <a:p>
             <a:pPr algn="l">
@@ -4737,6 +4996,14 @@
               </a:rPr>
               <a:t>WHAT REMAINS</a:t>
             </a:r>
+            <a:endParaRPr sz="1200" b="1">
+              <a:solidFill>
+                <a:srgbClr val="2D8B8B"/>
+              </a:solidFill>
+              <a:latin typeface="DejaVu Sans"/>
+              <a:ea typeface="DejaVu Sans"/>
+              <a:cs typeface="DejaVu Sans"/>
+            </a:endParaRPr>
           </a:p>
         </p:txBody>
       </p:sp>
@@ -4757,7 +5024,7 @@
           <a:noFill/>
         </p:spPr>
         <p:txBody>
-          <a:bodyPr wrap="square" lIns="0" rIns="0" tIns="0" bIns="0">
+          <a:bodyPr wrap="square" lIns="0" tIns="0" rIns="0" bIns="0">
             <a:spAutoFit/>
           </a:bodyPr>
           <a:lstStyle/>
@@ -4781,6 +5048,14 @@
               </a:rPr>
               <a:t>Some piping does not meet the 2D/3D dead-leg criterion.</a:t>
             </a:r>
+            <a:endParaRPr sz="1400" b="0">
+              <a:solidFill>
+                <a:srgbClr val="1C2833"/>
+              </a:solidFill>
+              <a:latin typeface="DejaVu Sans"/>
+              <a:ea typeface="DejaVu Sans"/>
+              <a:cs typeface="DejaVu Sans"/>
+            </a:endParaRPr>
           </a:p>
           <a:p>
             <a:pPr algn="l">
@@ -4802,6 +5077,14 @@
               </a:rPr>
               <a:t>Some diaphragm valves do not meet the self-draining requirement.</a:t>
             </a:r>
+            <a:endParaRPr sz="1400" b="0">
+              <a:solidFill>
+                <a:srgbClr val="1C2833"/>
+              </a:solidFill>
+              <a:latin typeface="DejaVu Sans"/>
+              <a:ea typeface="DejaVu Sans"/>
+              <a:cs typeface="DejaVu Sans"/>
+            </a:endParaRPr>
           </a:p>
           <a:p>
             <a:pPr algn="l">
@@ -4823,6 +5106,14 @@
               </a:rPr>
               <a:t>Some piping is not ASME BPE piping.</a:t>
             </a:r>
+            <a:endParaRPr sz="1400" b="0">
+              <a:solidFill>
+                <a:srgbClr val="1C2833"/>
+              </a:solidFill>
+              <a:latin typeface="DejaVu Sans"/>
+              <a:ea typeface="DejaVu Sans"/>
+              <a:cs typeface="DejaVu Sans"/>
+            </a:endParaRPr>
           </a:p>
         </p:txBody>
       </p:sp>
@@ -4843,7 +5134,7 @@
           <a:noFill/>
         </p:spPr>
         <p:txBody>
-          <a:bodyPr wrap="square" lIns="0" rIns="0" tIns="0" bIns="0" anchor="t"/>
+          <a:bodyPr wrap="square" lIns="0" tIns="0" rIns="0" bIns="0" anchor="t"/>
           <a:lstStyle/>
           <a:p>
             <a:pPr algn="l">
@@ -4865,6 +5156,14 @@
               </a:rPr>
               <a:t>WHAT WE WILL ADD</a:t>
             </a:r>
+            <a:endParaRPr sz="1200" b="1">
+              <a:solidFill>
+                <a:srgbClr val="2D8B8B"/>
+              </a:solidFill>
+              <a:latin typeface="DejaVu Sans"/>
+              <a:ea typeface="DejaVu Sans"/>
+              <a:cs typeface="DejaVu Sans"/>
+            </a:endParaRPr>
           </a:p>
         </p:txBody>
       </p:sp>
@@ -4885,7 +5184,7 @@
           <a:noFill/>
         </p:spPr>
         <p:txBody>
-          <a:bodyPr wrap="square" lIns="0" rIns="0" tIns="0" bIns="0">
+          <a:bodyPr wrap="square" lIns="0" tIns="0" rIns="0" bIns="0">
             <a:spAutoFit/>
           </a:bodyPr>
           <a:lstStyle/>
@@ -4909,6 +5208,14 @@
               </a:rPr>
               <a:t>After each system transfer, flush or clean with process solvent. Bioburden data support this step.</a:t>
             </a:r>
+            <a:endParaRPr sz="1400" b="0">
+              <a:solidFill>
+                <a:srgbClr val="1C2833"/>
+              </a:solidFill>
+              <a:latin typeface="DejaVu Sans"/>
+              <a:ea typeface="DejaVu Sans"/>
+              <a:cs typeface="DejaVu Sans"/>
+            </a:endParaRPr>
           </a:p>
           <a:p>
             <a:pPr algn="l">
@@ -4930,6 +5237,14 @@
               </a:rPr>
               <a:t>Write the flush, drain, purge, and disassembly requirements into the procedures.</a:t>
             </a:r>
+            <a:endParaRPr sz="1400" b="0">
+              <a:solidFill>
+                <a:srgbClr val="1C2833"/>
+              </a:solidFill>
+              <a:latin typeface="DejaVu Sans"/>
+              <a:ea typeface="DejaVu Sans"/>
+              <a:cs typeface="DejaVu Sans"/>
+            </a:endParaRPr>
           </a:p>
         </p:txBody>
       </p:sp>
@@ -5040,7 +5355,7 @@
           <a:noFill/>
         </p:spPr>
         <p:txBody>
-          <a:bodyPr wrap="square" lIns="0" rIns="0" tIns="0" bIns="0" anchor="t"/>
+          <a:bodyPr wrap="square" lIns="0" tIns="0" rIns="0" bIns="0" anchor="t"/>
           <a:lstStyle/>
           <a:p>
             <a:pPr algn="l">
@@ -5062,6 +5377,14 @@
               </a:rPr>
               <a:t>RESIDUAL RISK</a:t>
             </a:r>
+            <a:endParaRPr sz="1200" b="1">
+              <a:solidFill>
+                <a:srgbClr val="2D8B8B"/>
+              </a:solidFill>
+              <a:latin typeface="DejaVu Sans"/>
+              <a:ea typeface="DejaVu Sans"/>
+              <a:cs typeface="DejaVu Sans"/>
+            </a:endParaRPr>
           </a:p>
         </p:txBody>
       </p:sp>
@@ -5082,7 +5405,7 @@
           <a:noFill/>
         </p:spPr>
         <p:txBody>
-          <a:bodyPr wrap="square" lIns="0" rIns="0" tIns="0" bIns="0" anchor="t"/>
+          <a:bodyPr wrap="square" lIns="0" tIns="0" rIns="0" bIns="0" anchor="t"/>
           <a:lstStyle/>
           <a:p>
             <a:pPr algn="l">
@@ -5104,6 +5427,14 @@
               </a:rPr>
               <a:t>Low, once the tighter procedural controls are in place.</a:t>
             </a:r>
+            <a:endParaRPr sz="1600" b="0">
+              <a:solidFill>
+                <a:srgbClr val="1C2833"/>
+              </a:solidFill>
+              <a:latin typeface="DejaVu Sans"/>
+              <a:ea typeface="DejaVu Sans"/>
+              <a:cs typeface="DejaVu Sans"/>
+            </a:endParaRPr>
           </a:p>
         </p:txBody>
       </p:sp>
@@ -5124,7 +5455,7 @@
           <a:noFill/>
         </p:spPr>
         <p:txBody>
-          <a:bodyPr wrap="square" lIns="0" rIns="0" tIns="0" bIns="0" anchor="t"/>
+          <a:bodyPr wrap="square" lIns="0" tIns="0" rIns="0" bIns="0" anchor="t"/>
           <a:lstStyle/>
           <a:p>
             <a:pPr algn="l">
@@ -5146,6 +5477,14 @@
               </a:rPr>
               <a:t>DUE</a:t>
             </a:r>
+            <a:endParaRPr sz="1200" b="1">
+              <a:solidFill>
+                <a:srgbClr val="A8DADC"/>
+              </a:solidFill>
+              <a:latin typeface="DejaVu Sans"/>
+              <a:ea typeface="DejaVu Sans"/>
+              <a:cs typeface="DejaVu Sans"/>
+            </a:endParaRPr>
           </a:p>
         </p:txBody>
       </p:sp>
@@ -5166,7 +5505,7 @@
           <a:noFill/>
         </p:spPr>
         <p:txBody>
-          <a:bodyPr wrap="square" lIns="0" rIns="0" tIns="0" bIns="0" anchor="t"/>
+          <a:bodyPr wrap="square" lIns="0" tIns="0" rIns="0" bIns="0" anchor="t"/>
           <a:lstStyle/>
           <a:p>
             <a:pPr algn="l">
@@ -5188,6 +5527,14 @@
               </a:rPr>
               <a:t>November 5, 2026</a:t>
             </a:r>
+            <a:endParaRPr sz="2200" b="1">
+              <a:solidFill>
+                <a:srgbClr val="FFFFFF"/>
+              </a:solidFill>
+              <a:latin typeface="DejaVu Sans"/>
+              <a:ea typeface="DejaVu Sans"/>
+              <a:cs typeface="DejaVu Sans"/>
+            </a:endParaRPr>
           </a:p>
         </p:txBody>
       </p:sp>
@@ -5208,7 +5555,7 @@
           <a:noFill/>
         </p:spPr>
         <p:txBody>
-          <a:bodyPr wrap="square" lIns="0" rIns="0" tIns="0" bIns="0" anchor="t"/>
+          <a:bodyPr wrap="square" lIns="0" tIns="0" rIns="0" bIns="0" anchor="t"/>
           <a:lstStyle/>
           <a:p>
             <a:pPr algn="l">
@@ -5230,6 +5577,14 @@
               </a:rPr>
               <a:t>139788 Step 3  ·  Dead-leg and hold-up retrofit</a:t>
             </a:r>
+            <a:endParaRPr sz="1100" b="0">
+              <a:solidFill>
+                <a:srgbClr val="5D6D7E"/>
+              </a:solidFill>
+              <a:latin typeface="DejaVu Sans"/>
+              <a:ea typeface="DejaVu Sans"/>
+              <a:cs typeface="DejaVu Sans"/>
+            </a:endParaRPr>
           </a:p>
         </p:txBody>
       </p:sp>
@@ -5250,7 +5605,7 @@
           <a:noFill/>
         </p:spPr>
         <p:txBody>
-          <a:bodyPr wrap="square" lIns="0" rIns="0" tIns="0" bIns="0" anchor="t"/>
+          <a:bodyPr wrap="square" lIns="0" tIns="0" rIns="0" bIns="0" anchor="t"/>
           <a:lstStyle/>
           <a:p>
             <a:pPr algn="r">
@@ -5272,6 +5627,14 @@
               </a:rPr>
               <a:t>3  /  5</a:t>
             </a:r>
+            <a:endParaRPr sz="1100" b="0">
+              <a:solidFill>
+                <a:srgbClr val="5D6D7E"/>
+              </a:solidFill>
+              <a:latin typeface="DejaVu Sans"/>
+              <a:ea typeface="DejaVu Sans"/>
+              <a:cs typeface="DejaVu Sans"/>
+            </a:endParaRPr>
           </a:p>
         </p:txBody>
       </p:sp>
@@ -5284,7 +5647,7 @@
 </file>
 
 <file path=ppt/slides/slide4.xml><?xml version="1.0" encoding="utf-8"?>
-<p:sld xmlns:a="http://schemas.openxmlformats.org/drawingml/2006/main" xmlns:p="http://schemas.openxmlformats.org/presentationml/2006/main" xmlns:r="http://schemas.openxmlformats.org/officeDocument/2006/relationships">
+<p:sld xmlns:a="http://schemas.openxmlformats.org/drawingml/2006/main" xmlns:r="http://schemas.openxmlformats.org/officeDocument/2006/relationships" xmlns:p="http://schemas.openxmlformats.org/presentationml/2006/main">
   <p:cSld>
     <p:spTree>
       <p:nvGrpSpPr>
@@ -5398,7 +5761,7 @@
           <a:noFill/>
         </p:spPr>
         <p:txBody>
-          <a:bodyPr wrap="square" lIns="0" rIns="0" tIns="0" bIns="0" anchor="t"/>
+          <a:bodyPr wrap="square" lIns="0" tIns="0" rIns="0" bIns="0" anchor="t"/>
           <a:lstStyle/>
           <a:p>
             <a:pPr algn="l">
@@ -5420,6 +5783,14 @@
               </a:rPr>
               <a:t>Option 2: piping retrofit complete by February 6, 2027.</a:t>
             </a:r>
+            <a:endParaRPr sz="2600" b="1">
+              <a:solidFill>
+                <a:srgbClr val="1A2332"/>
+              </a:solidFill>
+              <a:latin typeface="DejaVu Sans"/>
+              <a:ea typeface="DejaVu Sans"/>
+              <a:cs typeface="DejaVu Sans"/>
+            </a:endParaRPr>
           </a:p>
         </p:txBody>
       </p:sp>
@@ -5440,7 +5811,7 @@
           <a:noFill/>
         </p:spPr>
         <p:txBody>
-          <a:bodyPr wrap="square" lIns="0" rIns="0" tIns="0" bIns="0" anchor="t"/>
+          <a:bodyPr wrap="square" lIns="0" tIns="0" rIns="0" bIns="0" anchor="t"/>
           <a:lstStyle/>
           <a:p>
             <a:pPr algn="l">
@@ -5462,6 +5833,14 @@
               </a:rPr>
               <a:t>This is the configuration for Pre-PPQ and PPQ.</a:t>
             </a:r>
+            <a:endParaRPr sz="1500" b="0">
+              <a:solidFill>
+                <a:srgbClr val="5D6D7E"/>
+              </a:solidFill>
+              <a:latin typeface="DejaVu Sans"/>
+              <a:ea typeface="DejaVu Sans"/>
+              <a:cs typeface="DejaVu Sans"/>
+            </a:endParaRPr>
           </a:p>
         </p:txBody>
       </p:sp>
@@ -5574,7 +5953,7 @@
           <a:noFill/>
         </p:spPr>
         <p:txBody>
-          <a:bodyPr wrap="square" lIns="0" rIns="0" tIns="0" bIns="0" anchor="t"/>
+          <a:bodyPr wrap="square" lIns="0" tIns="0" rIns="0" bIns="0" anchor="t"/>
           <a:lstStyle/>
           <a:p>
             <a:pPr algn="l">
@@ -5596,6 +5975,14 @@
               </a:rPr>
               <a:t>THE RETROFIT</a:t>
             </a:r>
+            <a:endParaRPr sz="1200" b="1">
+              <a:solidFill>
+                <a:srgbClr val="2D8B8B"/>
+              </a:solidFill>
+              <a:latin typeface="DejaVu Sans"/>
+              <a:ea typeface="DejaVu Sans"/>
+              <a:cs typeface="DejaVu Sans"/>
+            </a:endParaRPr>
           </a:p>
         </p:txBody>
       </p:sp>
@@ -5616,7 +6003,7 @@
           <a:noFill/>
         </p:spPr>
         <p:txBody>
-          <a:bodyPr wrap="square" lIns="0" rIns="0" tIns="0" bIns="0">
+          <a:bodyPr wrap="square" lIns="0" tIns="0" rIns="0" bIns="0">
             <a:spAutoFit/>
           </a:bodyPr>
           <a:lstStyle/>
@@ -5640,6 +6027,14 @@
               </a:rPr>
               <a:t>Rebuild the piping and vessels with hygienic T-valves and short-outlet tees meeting the 3D criterion.</a:t>
             </a:r>
+            <a:endParaRPr sz="1500" b="0">
+              <a:solidFill>
+                <a:srgbClr val="1C2833"/>
+              </a:solidFill>
+              <a:latin typeface="DejaVu Sans"/>
+              <a:ea typeface="DejaVu Sans"/>
+              <a:cs typeface="DejaVu Sans"/>
+            </a:endParaRPr>
           </a:p>
           <a:p>
             <a:pPr algn="l">
@@ -5661,6 +6056,14 @@
               </a:rPr>
               <a:t>Control dead legs, slope, and drainability.</a:t>
             </a:r>
+            <a:endParaRPr sz="1500" b="0">
+              <a:solidFill>
+                <a:srgbClr val="1C2833"/>
+              </a:solidFill>
+              <a:latin typeface="DejaVu Sans"/>
+              <a:ea typeface="DejaVu Sans"/>
+              <a:cs typeface="DejaVu Sans"/>
+            </a:endParaRPr>
           </a:p>
           <a:p>
             <a:pPr algn="l">
@@ -5682,6 +6085,14 @@
               </a:rPr>
               <a:t>Leave valves for a later CIP connection.</a:t>
             </a:r>
+            <a:endParaRPr sz="1500" b="0">
+              <a:solidFill>
+                <a:srgbClr val="1C2833"/>
+              </a:solidFill>
+              <a:latin typeface="DejaVu Sans"/>
+              <a:ea typeface="DejaVu Sans"/>
+              <a:cs typeface="DejaVu Sans"/>
+            </a:endParaRPr>
           </a:p>
         </p:txBody>
       </p:sp>
@@ -5702,7 +6113,7 @@
           <a:noFill/>
         </p:spPr>
         <p:txBody>
-          <a:bodyPr wrap="square" lIns="0" rIns="0" tIns="0" bIns="0" anchor="t"/>
+          <a:bodyPr wrap="square" lIns="0" tIns="0" rIns="0" bIns="0" anchor="t"/>
           <a:lstStyle/>
           <a:p>
             <a:pPr algn="l">
@@ -5724,6 +6135,14 @@
               </a:rPr>
               <a:t>RISK AND THE RESPONSE</a:t>
             </a:r>
+            <a:endParaRPr sz="1200" b="1">
+              <a:solidFill>
+                <a:srgbClr val="2D8B8B"/>
+              </a:solidFill>
+              <a:latin typeface="DejaVu Sans"/>
+              <a:ea typeface="DejaVu Sans"/>
+              <a:cs typeface="DejaVu Sans"/>
+            </a:endParaRPr>
           </a:p>
         </p:txBody>
       </p:sp>
@@ -5744,7 +6163,7 @@
           <a:noFill/>
         </p:spPr>
         <p:txBody>
-          <a:bodyPr wrap="square" lIns="0" rIns="0" tIns="0" bIns="0">
+          <a:bodyPr wrap="square" lIns="0" tIns="0" rIns="0" bIns="0">
             <a:spAutoFit/>
           </a:bodyPr>
           <a:lstStyle/>
@@ -5768,6 +6187,14 @@
               </a:rPr>
               <a:t>This is a new change control. The concern is an effect on product quality, and pre-use and post-use steps that are not yet sufficient.</a:t>
             </a:r>
+            <a:endParaRPr sz="1500" b="0">
+              <a:solidFill>
+                <a:srgbClr val="1C2833"/>
+              </a:solidFill>
+              <a:latin typeface="DejaVu Sans"/>
+              <a:ea typeface="DejaVu Sans"/>
+              <a:cs typeface="DejaVu Sans"/>
+            </a:endParaRPr>
           </a:p>
           <a:p>
             <a:pPr algn="l">
@@ -5789,6 +6216,14 @@
               </a:rPr>
               <a:t>Qualify the modified piping. Define the operating and cleaning sequence, and update the records.</a:t>
             </a:r>
+            <a:endParaRPr sz="1500" b="0">
+              <a:solidFill>
+                <a:srgbClr val="1C2833"/>
+              </a:solidFill>
+              <a:latin typeface="DejaVu Sans"/>
+              <a:ea typeface="DejaVu Sans"/>
+              <a:cs typeface="DejaVu Sans"/>
+            </a:endParaRPr>
           </a:p>
         </p:txBody>
       </p:sp>
@@ -5899,7 +6334,7 @@
           <a:noFill/>
         </p:spPr>
         <p:txBody>
-          <a:bodyPr wrap="square" lIns="0" rIns="0" tIns="0" bIns="0" anchor="t"/>
+          <a:bodyPr wrap="square" lIns="0" tIns="0" rIns="0" bIns="0" anchor="t"/>
           <a:lstStyle/>
           <a:p>
             <a:pPr algn="l">
@@ -5921,6 +6356,14 @@
               </a:rPr>
               <a:t>RESIDUAL RISK</a:t>
             </a:r>
+            <a:endParaRPr sz="1200" b="1">
+              <a:solidFill>
+                <a:srgbClr val="2D8B8B"/>
+              </a:solidFill>
+              <a:latin typeface="DejaVu Sans"/>
+              <a:ea typeface="DejaVu Sans"/>
+              <a:cs typeface="DejaVu Sans"/>
+            </a:endParaRPr>
           </a:p>
         </p:txBody>
       </p:sp>
@@ -5941,7 +6384,7 @@
           <a:noFill/>
         </p:spPr>
         <p:txBody>
-          <a:bodyPr wrap="square" lIns="0" rIns="0" tIns="0" bIns="0" anchor="t"/>
+          <a:bodyPr wrap="square" lIns="0" tIns="0" rIns="0" bIns="0" anchor="t"/>
           <a:lstStyle/>
           <a:p>
             <a:pPr algn="l">
@@ -5963,6 +6406,14 @@
               </a:rPr>
               <a:t>Low, with the modified hardware and the revised sequence.</a:t>
             </a:r>
+            <a:endParaRPr sz="1600" b="0">
+              <a:solidFill>
+                <a:srgbClr val="1C2833"/>
+              </a:solidFill>
+              <a:latin typeface="DejaVu Sans"/>
+              <a:ea typeface="DejaVu Sans"/>
+              <a:cs typeface="DejaVu Sans"/>
+            </a:endParaRPr>
           </a:p>
         </p:txBody>
       </p:sp>
@@ -5983,7 +6434,7 @@
           <a:noFill/>
         </p:spPr>
         <p:txBody>
-          <a:bodyPr wrap="square" lIns="0" rIns="0" tIns="0" bIns="0" anchor="t"/>
+          <a:bodyPr wrap="square" lIns="0" tIns="0" rIns="0" bIns="0" anchor="t"/>
           <a:lstStyle/>
           <a:p>
             <a:pPr algn="l">
@@ -6005,6 +6456,14 @@
               </a:rPr>
               <a:t>DUE</a:t>
             </a:r>
+            <a:endParaRPr sz="1200" b="1">
+              <a:solidFill>
+                <a:srgbClr val="A8DADC"/>
+              </a:solidFill>
+              <a:latin typeface="DejaVu Sans"/>
+              <a:ea typeface="DejaVu Sans"/>
+              <a:cs typeface="DejaVu Sans"/>
+            </a:endParaRPr>
           </a:p>
         </p:txBody>
       </p:sp>
@@ -6025,7 +6484,7 @@
           <a:noFill/>
         </p:spPr>
         <p:txBody>
-          <a:bodyPr wrap="square" lIns="0" rIns="0" tIns="0" bIns="0" anchor="t"/>
+          <a:bodyPr wrap="square" lIns="0" tIns="0" rIns="0" bIns="0" anchor="t"/>
           <a:lstStyle/>
           <a:p>
             <a:pPr algn="l">
@@ -6047,6 +6506,14 @@
               </a:rPr>
               <a:t>February 6, 2027</a:t>
             </a:r>
+            <a:endParaRPr sz="2200" b="1">
+              <a:solidFill>
+                <a:srgbClr val="FFFFFF"/>
+              </a:solidFill>
+              <a:latin typeface="DejaVu Sans"/>
+              <a:ea typeface="DejaVu Sans"/>
+              <a:cs typeface="DejaVu Sans"/>
+            </a:endParaRPr>
           </a:p>
         </p:txBody>
       </p:sp>
@@ -6067,7 +6534,7 @@
           <a:noFill/>
         </p:spPr>
         <p:txBody>
-          <a:bodyPr wrap="square" lIns="0" rIns="0" tIns="0" bIns="0" anchor="t"/>
+          <a:bodyPr wrap="square" lIns="0" tIns="0" rIns="0" bIns="0" anchor="t"/>
           <a:lstStyle/>
           <a:p>
             <a:pPr algn="l">
@@ -6089,6 +6556,14 @@
               </a:rPr>
               <a:t>139788 Step 3  ·  Dead-leg and hold-up retrofit</a:t>
             </a:r>
+            <a:endParaRPr sz="1100" b="0">
+              <a:solidFill>
+                <a:srgbClr val="5D6D7E"/>
+              </a:solidFill>
+              <a:latin typeface="DejaVu Sans"/>
+              <a:ea typeface="DejaVu Sans"/>
+              <a:cs typeface="DejaVu Sans"/>
+            </a:endParaRPr>
           </a:p>
         </p:txBody>
       </p:sp>
@@ -6109,7 +6584,7 @@
           <a:noFill/>
         </p:spPr>
         <p:txBody>
-          <a:bodyPr wrap="square" lIns="0" rIns="0" tIns="0" bIns="0" anchor="t"/>
+          <a:bodyPr wrap="square" lIns="0" tIns="0" rIns="0" bIns="0" anchor="t"/>
           <a:lstStyle/>
           <a:p>
             <a:pPr algn="r">
@@ -6131,6 +6606,14 @@
               </a:rPr>
               <a:t>4  /  5</a:t>
             </a:r>
+            <a:endParaRPr sz="1100" b="0">
+              <a:solidFill>
+                <a:srgbClr val="5D6D7E"/>
+              </a:solidFill>
+              <a:latin typeface="DejaVu Sans"/>
+              <a:ea typeface="DejaVu Sans"/>
+              <a:cs typeface="DejaVu Sans"/>
+            </a:endParaRPr>
           </a:p>
         </p:txBody>
       </p:sp>
@@ -6143,7 +6626,7 @@
 </file>
 
 <file path=ppt/slides/slide5.xml><?xml version="1.0" encoding="utf-8"?>
-<p:sld xmlns:a="http://schemas.openxmlformats.org/drawingml/2006/main" xmlns:p="http://schemas.openxmlformats.org/presentationml/2006/main" xmlns:r="http://schemas.openxmlformats.org/officeDocument/2006/relationships">
+<p:sld xmlns:a="http://schemas.openxmlformats.org/drawingml/2006/main" xmlns:r="http://schemas.openxmlformats.org/officeDocument/2006/relationships" xmlns:p="http://schemas.openxmlformats.org/presentationml/2006/main">
   <p:cSld>
     <p:spTree>
       <p:nvGrpSpPr>
@@ -6257,7 +6740,7 @@
           <a:noFill/>
         </p:spPr>
         <p:txBody>
-          <a:bodyPr wrap="square" lIns="0" rIns="0" tIns="0" bIns="0" anchor="t"/>
+          <a:bodyPr wrap="square" lIns="0" tIns="0" rIns="0" bIns="0" anchor="t"/>
           <a:lstStyle/>
           <a:p>
             <a:pPr algn="l">
@@ -6279,6 +6762,14 @@
               </a:rPr>
               <a:t>Option 3 adds CIP, five months after Option 2.</a:t>
             </a:r>
+            <a:endParaRPr sz="2600" b="1">
+              <a:solidFill>
+                <a:srgbClr val="1A2332"/>
+              </a:solidFill>
+              <a:latin typeface="DejaVu Sans"/>
+              <a:ea typeface="DejaVu Sans"/>
+              <a:cs typeface="DejaVu Sans"/>
+            </a:endParaRPr>
           </a:p>
         </p:txBody>
       </p:sp>
@@ -6299,7 +6790,7 @@
           <a:noFill/>
         </p:spPr>
         <p:txBody>
-          <a:bodyPr wrap="square" lIns="0" rIns="0" tIns="0" bIns="0" anchor="t"/>
+          <a:bodyPr wrap="square" lIns="0" tIns="0" rIns="0" bIns="0" anchor="t"/>
           <a:lstStyle/>
           <a:p>
             <a:pPr algn="l">
@@ -6321,6 +6812,14 @@
               </a:rPr>
               <a:t>This is the configuration for commercial manufacture. It is built on the Option 2 piping.</a:t>
             </a:r>
+            <a:endParaRPr sz="1500" b="0">
+              <a:solidFill>
+                <a:srgbClr val="5D6D7E"/>
+              </a:solidFill>
+              <a:latin typeface="DejaVu Sans"/>
+              <a:ea typeface="DejaVu Sans"/>
+              <a:cs typeface="DejaVu Sans"/>
+            </a:endParaRPr>
           </a:p>
         </p:txBody>
       </p:sp>
@@ -6433,7 +6932,7 @@
           <a:noFill/>
         </p:spPr>
         <p:txBody>
-          <a:bodyPr wrap="square" lIns="0" rIns="0" tIns="0" bIns="0" anchor="t"/>
+          <a:bodyPr wrap="square" lIns="0" tIns="0" rIns="0" bIns="0" anchor="t"/>
           <a:lstStyle/>
           <a:p>
             <a:pPr algn="l">
@@ -6455,6 +6954,14 @@
               </a:rPr>
               <a:t>WHAT CIP ADDS</a:t>
             </a:r>
+            <a:endParaRPr sz="1200" b="1">
+              <a:solidFill>
+                <a:srgbClr val="2D8B8B"/>
+              </a:solidFill>
+              <a:latin typeface="DejaVu Sans"/>
+              <a:ea typeface="DejaVu Sans"/>
+              <a:cs typeface="DejaVu Sans"/>
+            </a:endParaRPr>
           </a:p>
         </p:txBody>
       </p:sp>
@@ -6475,7 +6982,7 @@
           <a:noFill/>
         </p:spPr>
         <p:txBody>
-          <a:bodyPr wrap="square" lIns="0" rIns="0" tIns="0" bIns="0">
+          <a:bodyPr wrap="square" lIns="0" tIns="0" rIns="0" bIns="0">
             <a:spAutoFit/>
           </a:bodyPr>
           <a:lstStyle/>
@@ -6499,6 +7006,14 @@
               </a:rPr>
               <a:t>Clean-in-place on the retrofitted piping.</a:t>
             </a:r>
+            <a:endParaRPr sz="1500" b="0">
+              <a:solidFill>
+                <a:srgbClr val="1C2833"/>
+              </a:solidFill>
+              <a:latin typeface="DejaVu Sans"/>
+              <a:ea typeface="DejaVu Sans"/>
+              <a:cs typeface="DejaVu Sans"/>
+            </a:endParaRPr>
           </a:p>
           <a:p>
             <a:pPr algn="l">
@@ -6520,6 +7035,14 @@
               </a:rPr>
               <a:t>Slope, drainage, and removal of dead legs.</a:t>
             </a:r>
+            <a:endParaRPr sz="1500" b="0">
+              <a:solidFill>
+                <a:srgbClr val="1C2833"/>
+              </a:solidFill>
+              <a:latin typeface="DejaVu Sans"/>
+              <a:ea typeface="DejaVu Sans"/>
+              <a:cs typeface="DejaVu Sans"/>
+            </a:endParaRPr>
           </a:p>
           <a:p>
             <a:pPr algn="l">
@@ -6541,6 +7064,14 @@
               </a:rPr>
               <a:t>Pre-use flush, cleaning, disinfection, and purge, all done in place.</a:t>
             </a:r>
+            <a:endParaRPr sz="1500" b="0">
+              <a:solidFill>
+                <a:srgbClr val="1C2833"/>
+              </a:solidFill>
+              <a:latin typeface="DejaVu Sans"/>
+              <a:ea typeface="DejaVu Sans"/>
+              <a:cs typeface="DejaVu Sans"/>
+            </a:endParaRPr>
           </a:p>
         </p:txBody>
       </p:sp>
@@ -6561,7 +7092,7 @@
           <a:noFill/>
         </p:spPr>
         <p:txBody>
-          <a:bodyPr wrap="square" lIns="0" rIns="0" tIns="0" bIns="0" anchor="t"/>
+          <a:bodyPr wrap="square" lIns="0" tIns="0" rIns="0" bIns="0" anchor="t"/>
           <a:lstStyle/>
           <a:p>
             <a:pPr algn="l">
@@ -6583,6 +7114,14 @@
               </a:rPr>
               <a:t>RISK AND THE RESPONSE</a:t>
             </a:r>
+            <a:endParaRPr sz="1200" b="1">
+              <a:solidFill>
+                <a:srgbClr val="2D8B8B"/>
+              </a:solidFill>
+              <a:latin typeface="DejaVu Sans"/>
+              <a:ea typeface="DejaVu Sans"/>
+              <a:cs typeface="DejaVu Sans"/>
+            </a:endParaRPr>
           </a:p>
         </p:txBody>
       </p:sp>
@@ -6603,7 +7142,7 @@
           <a:noFill/>
         </p:spPr>
         <p:txBody>
-          <a:bodyPr wrap="square" lIns="0" rIns="0" tIns="0" bIns="0">
+          <a:bodyPr wrap="square" lIns="0" tIns="0" rIns="0" bIns="0">
             <a:spAutoFit/>
           </a:bodyPr>
           <a:lstStyle/>
@@ -6627,6 +7166,14 @@
               </a:rPr>
               <a:t>The design may be incomplete, and the CIP sequence and controls may be incomplete.</a:t>
             </a:r>
+            <a:endParaRPr sz="1500" b="0">
+              <a:solidFill>
+                <a:srgbClr val="1C2833"/>
+              </a:solidFill>
+              <a:latin typeface="DejaVu Sans"/>
+              <a:ea typeface="DejaVu Sans"/>
+              <a:cs typeface="DejaVu Sans"/>
+            </a:endParaRPr>
           </a:p>
           <a:p>
             <a:pPr algn="l">
@@ -6648,6 +7195,14 @@
               </a:rPr>
               <a:t>Qualify the system as a whole. Update the SOP and bring the requirements into routine use.</a:t>
             </a:r>
+            <a:endParaRPr sz="1500" b="0">
+              <a:solidFill>
+                <a:srgbClr val="1C2833"/>
+              </a:solidFill>
+              <a:latin typeface="DejaVu Sans"/>
+              <a:ea typeface="DejaVu Sans"/>
+              <a:cs typeface="DejaVu Sans"/>
+            </a:endParaRPr>
           </a:p>
         </p:txBody>
       </p:sp>
@@ -6758,7 +7313,7 @@
           <a:noFill/>
         </p:spPr>
         <p:txBody>
-          <a:bodyPr wrap="square" lIns="0" rIns="0" tIns="0" bIns="0" anchor="t"/>
+          <a:bodyPr wrap="square" lIns="0" tIns="0" rIns="0" bIns="0" anchor="t"/>
           <a:lstStyle/>
           <a:p>
             <a:pPr algn="l">
@@ -6780,6 +7335,14 @@
               </a:rPr>
               <a:t>RESIDUAL RISK</a:t>
             </a:r>
+            <a:endParaRPr sz="1200" b="1">
+              <a:solidFill>
+                <a:srgbClr val="2D8B8B"/>
+              </a:solidFill>
+              <a:latin typeface="DejaVu Sans"/>
+              <a:ea typeface="DejaVu Sans"/>
+              <a:cs typeface="DejaVu Sans"/>
+            </a:endParaRPr>
           </a:p>
         </p:txBody>
       </p:sp>
@@ -6800,7 +7363,7 @@
           <a:noFill/>
         </p:spPr>
         <p:txBody>
-          <a:bodyPr wrap="square" lIns="0" rIns="0" tIns="0" bIns="0" anchor="t"/>
+          <a:bodyPr wrap="square" lIns="0" tIns="0" rIns="0" bIns="0" anchor="t"/>
           <a:lstStyle/>
           <a:p>
             <a:pPr algn="l">
@@ -6822,6 +7385,14 @@
               </a:rPr>
               <a:t>Low, with the revised piping and the CIP cycle.</a:t>
             </a:r>
+            <a:endParaRPr sz="1600" b="0">
+              <a:solidFill>
+                <a:srgbClr val="1C2833"/>
+              </a:solidFill>
+              <a:latin typeface="DejaVu Sans"/>
+              <a:ea typeface="DejaVu Sans"/>
+              <a:cs typeface="DejaVu Sans"/>
+            </a:endParaRPr>
           </a:p>
         </p:txBody>
       </p:sp>
@@ -6842,7 +7413,7 @@
           <a:noFill/>
         </p:spPr>
         <p:txBody>
-          <a:bodyPr wrap="square" lIns="0" rIns="0" tIns="0" bIns="0" anchor="t"/>
+          <a:bodyPr wrap="square" lIns="0" tIns="0" rIns="0" bIns="0" anchor="t"/>
           <a:lstStyle/>
           <a:p>
             <a:pPr algn="l">
@@ -6864,6 +7435,14 @@
               </a:rPr>
               <a:t>DUE</a:t>
             </a:r>
+            <a:endParaRPr sz="1200" b="1">
+              <a:solidFill>
+                <a:srgbClr val="A8DADC"/>
+              </a:solidFill>
+              <a:latin typeface="DejaVu Sans"/>
+              <a:ea typeface="DejaVu Sans"/>
+              <a:cs typeface="DejaVu Sans"/>
+            </a:endParaRPr>
           </a:p>
         </p:txBody>
       </p:sp>
@@ -6884,7 +7463,7 @@
           <a:noFill/>
         </p:spPr>
         <p:txBody>
-          <a:bodyPr wrap="square" lIns="0" rIns="0" tIns="0" bIns="0">
+          <a:bodyPr wrap="square" lIns="0" tIns="0" rIns="0" bIns="0">
             <a:spAutoFit/>
           </a:bodyPr>
           <a:lstStyle/>
@@ -6908,6 +7487,14 @@
               </a:rPr>
               <a:t>5 months after</a:t>
             </a:r>
+            <a:endParaRPr sz="1800" b="1">
+              <a:solidFill>
+                <a:srgbClr val="FFFFFF"/>
+              </a:solidFill>
+              <a:latin typeface="DejaVu Sans"/>
+              <a:ea typeface="DejaVu Sans"/>
+              <a:cs typeface="DejaVu Sans"/>
+            </a:endParaRPr>
           </a:p>
           <a:p>
             <a:pPr algn="l">
@@ -6929,6 +7516,14 @@
               </a:rPr>
               <a:t>Option 2</a:t>
             </a:r>
+            <a:endParaRPr sz="1800" b="1">
+              <a:solidFill>
+                <a:srgbClr val="FFFFFF"/>
+              </a:solidFill>
+              <a:latin typeface="DejaVu Sans"/>
+              <a:ea typeface="DejaVu Sans"/>
+              <a:cs typeface="DejaVu Sans"/>
+            </a:endParaRPr>
           </a:p>
         </p:txBody>
       </p:sp>
@@ -6949,7 +7544,7 @@
           <a:noFill/>
         </p:spPr>
         <p:txBody>
-          <a:bodyPr wrap="square" lIns="0" rIns="0" tIns="0" bIns="0" anchor="t"/>
+          <a:bodyPr wrap="square" lIns="0" tIns="0" rIns="0" bIns="0" anchor="t"/>
           <a:lstStyle/>
           <a:p>
             <a:pPr algn="l">
@@ -6971,6 +7566,14 @@
               </a:rPr>
               <a:t>139788 Step 3  ·  Dead-leg and hold-up retrofit</a:t>
             </a:r>
+            <a:endParaRPr sz="1100" b="0">
+              <a:solidFill>
+                <a:srgbClr val="5D6D7E"/>
+              </a:solidFill>
+              <a:latin typeface="DejaVu Sans"/>
+              <a:ea typeface="DejaVu Sans"/>
+              <a:cs typeface="DejaVu Sans"/>
+            </a:endParaRPr>
           </a:p>
         </p:txBody>
       </p:sp>
@@ -6991,7 +7594,7 @@
           <a:noFill/>
         </p:spPr>
         <p:txBody>
-          <a:bodyPr wrap="square" lIns="0" rIns="0" tIns="0" bIns="0" anchor="t"/>
+          <a:bodyPr wrap="square" lIns="0" tIns="0" rIns="0" bIns="0" anchor="t"/>
           <a:lstStyle/>
           <a:p>
             <a:pPr algn="r">
@@ -7013,6 +7616,14 @@
               </a:rPr>
               <a:t>5  /  5</a:t>
             </a:r>
+            <a:endParaRPr sz="1100" b="0">
+              <a:solidFill>
+                <a:srgbClr val="5D6D7E"/>
+              </a:solidFill>
+              <a:latin typeface="DejaVu Sans"/>
+              <a:ea typeface="DejaVu Sans"/>
+              <a:cs typeface="DejaVu Sans"/>
+            </a:endParaRPr>
           </a:p>
         </p:txBody>
       </p:sp>
@@ -7340,6 +7951,10 @@
       </a:style>
     </a:lnDef>
   </a:objectDefaults>
-  <a:extraClrSchemeLst/>
+  <a:extLst>
+    <a:ext uri="{05A4C25C-085E-4340-85A3-A5531E510DB2}">
+      <thm15:themeFamily xmlns:thm15="http://schemas.microsoft.com/office/thememl/2012/main" name="Office Theme" id="{62F939B6-93AF-4DB8-9C6B-D6C7DFDC589F}" vid="{4A3C46E8-61CC-4603-A589-7422A47A8E4A}"/>
+    </a:ext>
+  </a:extLst>
 </a:theme>
 </file>
</xml_diff>

<commit_message>
Correct Option 2 risk wording and align the Option 1 slide.
Pre-use and post-use wording now refers to the risk assessment. Option 1 uses the same risk-and-response card as Options 2 and 3.

Co-authored-by: peterli0913 <peterli0913@users.noreply.github.com>
</commit_message>
<xml_diff>
--- a/139788 Step 3 Dead-leg and Hold-up Retrofit_EN.pptx
+++ b/139788 Step 3 Dead-leg and Hold-up Retrofit_EN.pptx
@@ -4677,8 +4677,8 @@
         </p:nvSpPr>
         <p:spPr>
           <a:xfrm>
-            <a:off x="502920" y="1078992"/>
-            <a:ext cx="10972800" cy="256032"/>
+            <a:off x="502920" y="1170432"/>
+            <a:ext cx="10972800" cy="292608"/>
           </a:xfrm>
           <a:prstGeom prst="rect">
             <a:avLst/>
@@ -4721,24 +4721,24 @@
       </p:sp>
       <p:sp>
         <p:nvSpPr>
-          <p:cNvPr id="6" name="Rectangle 5"/>
+          <p:cNvPr id="9" name="Rectangle 8"/>
           <p:cNvSpPr/>
           <p:nvPr/>
         </p:nvSpPr>
         <p:spPr>
           <a:xfrm>
-            <a:off x="502920" y="1417320"/>
-            <a:ext cx="11201400" cy="1115568"/>
+            <a:off x="502920" y="1645920"/>
+            <a:ext cx="5486400" cy="3063240"/>
           </a:xfrm>
           <a:prstGeom prst="rect">
             <a:avLst/>
           </a:prstGeom>
           <a:solidFill>
-            <a:srgbClr val="F8EEEE"/>
+            <a:srgbClr val="F7FBFB"/>
           </a:solidFill>
           <a:ln w="12700">
             <a:solidFill>
-              <a:srgbClr val="E4C8C8"/>
+              <a:srgbClr val="D5E3E3"/>
             </a:solidFill>
           </a:ln>
           <a:effectLst/>
@@ -4767,114 +4767,14 @@
       </p:sp>
       <p:sp>
         <p:nvSpPr>
-          <p:cNvPr id="7" name="TextBox 6"/>
-          <p:cNvSpPr txBox="1"/>
-          <p:nvPr/>
-        </p:nvSpPr>
-        <p:spPr>
-          <a:xfrm>
-            <a:off x="685800" y="1499616"/>
-            <a:ext cx="3657600" cy="201168"/>
-          </a:xfrm>
-          <a:prstGeom prst="rect">
-            <a:avLst/>
-          </a:prstGeom>
-          <a:noFill/>
-        </p:spPr>
-        <p:txBody>
-          <a:bodyPr wrap="square" lIns="0" tIns="0" rIns="0" bIns="0" anchor="t"/>
-          <a:lstStyle/>
-          <a:p>
-            <a:pPr algn="l">
-              <a:spcBef>
-                <a:spcPts val="0"/>
-              </a:spcBef>
-              <a:spcAft>
-                <a:spcPts val="0"/>
-              </a:spcAft>
-            </a:pPr>
-            <a:r>
-              <a:rPr sz="1200" b="1">
-                <a:solidFill>
-                  <a:srgbClr val="8C3A3A"/>
-                </a:solidFill>
-                <a:latin typeface="DejaVu Sans"/>
-                <a:ea typeface="DejaVu Sans"/>
-                <a:cs typeface="DejaVu Sans"/>
-              </a:rPr>
-              <a:t>POTENTIAL RISK</a:t>
-            </a:r>
-            <a:endParaRPr sz="1200" b="1">
-              <a:solidFill>
-                <a:srgbClr val="8C3A3A"/>
-              </a:solidFill>
-              <a:latin typeface="DejaVu Sans"/>
-              <a:ea typeface="DejaVu Sans"/>
-              <a:cs typeface="DejaVu Sans"/>
-            </a:endParaRPr>
-          </a:p>
-        </p:txBody>
-      </p:sp>
-      <p:sp>
-        <p:nvSpPr>
-          <p:cNvPr id="8" name="TextBox 7"/>
-          <p:cNvSpPr txBox="1"/>
-          <p:nvPr/>
-        </p:nvSpPr>
-        <p:spPr>
-          <a:xfrm>
-            <a:off x="685800" y="1737360"/>
-            <a:ext cx="10835640" cy="658368"/>
-          </a:xfrm>
-          <a:prstGeom prst="rect">
-            <a:avLst/>
-          </a:prstGeom>
-          <a:noFill/>
-        </p:spPr>
-        <p:txBody>
-          <a:bodyPr wrap="square" lIns="0" tIns="0" rIns="0" bIns="0" anchor="t"/>
-          <a:lstStyle/>
-          <a:p>
-            <a:pPr algn="l">
-              <a:spcBef>
-                <a:spcPts val="0"/>
-              </a:spcBef>
-              <a:spcAft>
-                <a:spcPts val="0"/>
-              </a:spcAft>
-            </a:pPr>
-            <a:r>
-              <a:rPr sz="1500" b="0">
-                <a:solidFill>
-                  <a:srgbClr val="1C2833"/>
-                </a:solidFill>
-                <a:latin typeface="DejaVu Sans"/>
-                <a:ea typeface="DejaVu Sans"/>
-                <a:cs typeface="DejaVu Sans"/>
-              </a:rPr>
-              <a:t>Hold-up in the piping can degrade the material, support microbial growth, or cause cross-contamination. The flush, drain, purge, and disassembly required after each use are not defined.</a:t>
-            </a:r>
-            <a:endParaRPr sz="1500" b="0">
-              <a:solidFill>
-                <a:srgbClr val="1C2833"/>
-              </a:solidFill>
-              <a:latin typeface="DejaVu Sans"/>
-              <a:ea typeface="DejaVu Sans"/>
-              <a:cs typeface="DejaVu Sans"/>
-            </a:endParaRPr>
-          </a:p>
-        </p:txBody>
-      </p:sp>
-      <p:sp>
-        <p:nvSpPr>
-          <p:cNvPr id="9" name="Rectangle 8"/>
+          <p:cNvPr id="10" name="Rectangle 9"/>
           <p:cNvSpPr/>
           <p:nvPr/>
         </p:nvSpPr>
         <p:spPr>
           <a:xfrm>
-            <a:off x="502920" y="2697480"/>
-            <a:ext cx="5486400" cy="2011680"/>
+            <a:off x="6172200" y="1645920"/>
+            <a:ext cx="5532120" cy="3063240"/>
           </a:xfrm>
           <a:prstGeom prst="rect">
             <a:avLst/>
@@ -4913,60 +4813,14 @@
       </p:sp>
       <p:sp>
         <p:nvSpPr>
-          <p:cNvPr id="10" name="Rectangle 9"/>
-          <p:cNvSpPr/>
-          <p:nvPr/>
-        </p:nvSpPr>
-        <p:spPr>
-          <a:xfrm>
-            <a:off x="6172200" y="2697480"/>
-            <a:ext cx="5532120" cy="2011680"/>
-          </a:xfrm>
-          <a:prstGeom prst="rect">
-            <a:avLst/>
-          </a:prstGeom>
-          <a:solidFill>
-            <a:srgbClr val="F7FBFB"/>
-          </a:solidFill>
-          <a:ln w="12700">
-            <a:solidFill>
-              <a:srgbClr val="D5E3E3"/>
-            </a:solidFill>
-          </a:ln>
-          <a:effectLst/>
-        </p:spPr>
-        <p:style>
-          <a:lnRef idx="1">
-            <a:schemeClr val="accent1"/>
-          </a:lnRef>
-          <a:fillRef idx="3">
-            <a:schemeClr val="accent1"/>
-          </a:fillRef>
-          <a:effectRef idx="2">
-            <a:schemeClr val="accent1"/>
-          </a:effectRef>
-          <a:fontRef idx="minor">
-            <a:schemeClr val="lt1"/>
-          </a:fontRef>
-        </p:style>
-        <p:txBody>
-          <a:bodyPr rtlCol="0" anchor="ctr"/>
-          <a:lstStyle/>
-          <a:p>
-            <a:pPr algn="ctr"/>
-          </a:p>
-        </p:txBody>
-      </p:sp>
-      <p:sp>
-        <p:nvSpPr>
           <p:cNvPr id="11" name="TextBox 10"/>
           <p:cNvSpPr txBox="1"/>
           <p:nvPr/>
         </p:nvSpPr>
         <p:spPr>
           <a:xfrm>
-            <a:off x="713232" y="2816352"/>
-            <a:ext cx="5029200" cy="219456"/>
+            <a:off x="713232" y="1810512"/>
+            <a:ext cx="5029200" cy="256032"/>
           </a:xfrm>
           <a:prstGeom prst="rect">
             <a:avLst/>
@@ -5015,8 +4869,8 @@
         </p:nvSpPr>
         <p:spPr>
           <a:xfrm>
-            <a:off x="713232" y="3090672"/>
-            <a:ext cx="5029200" cy="1463040"/>
+            <a:off x="713232" y="2194560"/>
+            <a:ext cx="5029200" cy="2240280"/>
           </a:xfrm>
           <a:prstGeom prst="rect">
             <a:avLst/>
@@ -5038,7 +4892,7 @@
               </a:spcAft>
             </a:pPr>
             <a:r>
-              <a:rPr sz="1400" b="0">
+              <a:rPr sz="1500" b="0">
                 <a:solidFill>
                   <a:srgbClr val="1C2833"/>
                 </a:solidFill>
@@ -5067,7 +4921,7 @@
               </a:spcAft>
             </a:pPr>
             <a:r>
-              <a:rPr sz="1400" b="0">
+              <a:rPr sz="1500" b="0">
                 <a:solidFill>
                   <a:srgbClr val="1C2833"/>
                 </a:solidFill>
@@ -5096,7 +4950,7 @@
               </a:spcAft>
             </a:pPr>
             <a:r>
-              <a:rPr sz="1400" b="0">
+              <a:rPr sz="1500" b="0">
                 <a:solidFill>
                   <a:srgbClr val="1C2833"/>
                 </a:solidFill>
@@ -5125,8 +4979,8 @@
         </p:nvSpPr>
         <p:spPr>
           <a:xfrm>
-            <a:off x="6382512" y="2816352"/>
-            <a:ext cx="5029200" cy="219456"/>
+            <a:off x="6382512" y="1810512"/>
+            <a:ext cx="5029200" cy="256032"/>
           </a:xfrm>
           <a:prstGeom prst="rect">
             <a:avLst/>
@@ -5154,7 +5008,7 @@
                 <a:ea typeface="DejaVu Sans"/>
                 <a:cs typeface="DejaVu Sans"/>
               </a:rPr>
-              <a:t>WHAT WE WILL ADD</a:t>
+              <a:t>RISK AND THE RESPONSE</a:t>
             </a:r>
             <a:endParaRPr sz="1200" b="1">
               <a:solidFill>
@@ -5175,8 +5029,8 @@
         </p:nvSpPr>
         <p:spPr>
           <a:xfrm>
-            <a:off x="6382512" y="3090672"/>
-            <a:ext cx="5074920" cy="1463040"/>
+            <a:off x="6382512" y="2194560"/>
+            <a:ext cx="5074920" cy="2240280"/>
           </a:xfrm>
           <a:prstGeom prst="rect">
             <a:avLst/>
@@ -5198,7 +5052,7 @@
               </a:spcAft>
             </a:pPr>
             <a:r>
-              <a:rPr sz="1400" b="0">
+              <a:rPr sz="1500" b="0">
                 <a:solidFill>
                   <a:srgbClr val="1C2833"/>
                 </a:solidFill>
@@ -5206,7 +5060,7 @@
                 <a:ea typeface="DejaVu Sans"/>
                 <a:cs typeface="DejaVu Sans"/>
               </a:rPr>
-              <a:t>After each system transfer, flush or clean with process solvent. Bioburden data support this step.</a:t>
+              <a:t>Hold-up in the piping can degrade the material, support microbial growth, or cause cross-contamination. The flush, drain, purge, and disassembly required after each use are not defined.</a:t>
             </a:r>
             <a:endParaRPr sz="1400" b="0">
               <a:solidFill>
@@ -5227,7 +5081,7 @@
               </a:spcAft>
             </a:pPr>
             <a:r>
-              <a:rPr sz="1400" b="0">
+              <a:rPr sz="1500" b="0">
                 <a:solidFill>
                   <a:srgbClr val="1C2833"/>
                 </a:solidFill>
@@ -5235,7 +5089,7 @@
                 <a:ea typeface="DejaVu Sans"/>
                 <a:cs typeface="DejaVu Sans"/>
               </a:rPr>
-              <a:t>Write the flush, drain, purge, and disassembly requirements into the procedures.</a:t>
+              <a:t>After each system transfer, flush or clean with process solvent. Bioburden data support this step. Write the flush, drain, purge, and disassembly requirements into the procedures.</a:t>
             </a:r>
             <a:endParaRPr sz="1400" b="0">
               <a:solidFill>
@@ -6185,7 +6039,7 @@
                 <a:ea typeface="DejaVu Sans"/>
                 <a:cs typeface="DejaVu Sans"/>
               </a:rPr>
-              <a:t>This is a new change control. The concern is an effect on product quality, and pre-use and post-use steps that are not yet sufficient.</a:t>
+              <a:t>This is a new change control. The concern is an effect on product quality, and the risk assessment of pre-use and post-use operations is not yet sufficient.</a:t>
             </a:r>
             <a:endParaRPr sz="1500" b="0">
               <a:solidFill>

</xml_diff>